<commit_message>
feat(indicador): cadena de proveedores con findic.cl como respaldo de mindicador.cl
- servicios/indicador_dolar.py: PROVEEDORES con mindicador.cl y findic.cl,
  intento en orden, aviso de cual se uso y respaldo local como ultima instancia
- tests: 2 pruebas nuevas de la cadena de respaldo (21 en total)
- README, sitio web, presentacion y guion de la defensa actualizados
</commit_message>
<xml_diff>
--- a/docs/ES3_114-2A-F2_presentacion.pptx
+++ b/docs/ES3_114-2A-F2_presentacion.pptx
@@ -2,26 +2,26 @@
 <file path=ppt/presentation.xml><?xml version="1.0" encoding="utf-8"?>
 <p:presentation xmlns:p="http://schemas.openxmlformats.org/presentationml/2006/main">
   <p:sldMasterIdLst>
-    <p:sldMasterId xmlns:r="http://schemas.openxmlformats.org/officeDocument/2006/relationships" id="2147483648" r:id="R07cc0b2dd8554dfb"/>
+    <p:sldMasterId xmlns:r="http://schemas.openxmlformats.org/officeDocument/2006/relationships" id="2147483648" r:id="R2c7c2c85d44a4632"/>
   </p:sldMasterIdLst>
   <p:notesMasterIdLst>
-    <p:notesMasterId xmlns:r="http://schemas.openxmlformats.org/officeDocument/2006/relationships" r:id="R29c77562d8a44b14"/>
+    <p:notesMasterId xmlns:r="http://schemas.openxmlformats.org/officeDocument/2006/relationships" r:id="R365e1a8429154ae3"/>
   </p:notesMasterIdLst>
   <p:sldIdLst>
-    <p:sldId xmlns:r="http://schemas.openxmlformats.org/officeDocument/2006/relationships" id="256" r:id="R0dda795033ea4096"/>
-    <p:sldId xmlns:r="http://schemas.openxmlformats.org/officeDocument/2006/relationships" id="257" r:id="R9088ead0eebb42d5"/>
-    <p:sldId xmlns:r="http://schemas.openxmlformats.org/officeDocument/2006/relationships" id="258" r:id="Rb2f35abcf61646e7"/>
-    <p:sldId xmlns:r="http://schemas.openxmlformats.org/officeDocument/2006/relationships" id="259" r:id="Rcb39b91b215449a3"/>
-    <p:sldId xmlns:r="http://schemas.openxmlformats.org/officeDocument/2006/relationships" id="260" r:id="Rd8c5cb438506438a"/>
-    <p:sldId xmlns:r="http://schemas.openxmlformats.org/officeDocument/2006/relationships" id="261" r:id="R999ee0d2857e4d2c"/>
-    <p:sldId xmlns:r="http://schemas.openxmlformats.org/officeDocument/2006/relationships" id="262" r:id="Rb8ab130e5ae249c8"/>
-    <p:sldId xmlns:r="http://schemas.openxmlformats.org/officeDocument/2006/relationships" id="263" r:id="Raaf6776201ab429b"/>
-    <p:sldId xmlns:r="http://schemas.openxmlformats.org/officeDocument/2006/relationships" id="264" r:id="Rdce3afeca3094957"/>
-    <p:sldId xmlns:r="http://schemas.openxmlformats.org/officeDocument/2006/relationships" id="265" r:id="R9fb72673344c43ad"/>
-    <p:sldId xmlns:r="http://schemas.openxmlformats.org/officeDocument/2006/relationships" id="266" r:id="R882320caf04f4760"/>
-    <p:sldId xmlns:r="http://schemas.openxmlformats.org/officeDocument/2006/relationships" id="267" r:id="R1f69fcf782bb44ed"/>
-    <p:sldId xmlns:r="http://schemas.openxmlformats.org/officeDocument/2006/relationships" id="268" r:id="R5cb85202f7f34045"/>
-    <p:sldId xmlns:r="http://schemas.openxmlformats.org/officeDocument/2006/relationships" id="269" r:id="Ra2962b4e56394e5e"/>
+    <p:sldId xmlns:r="http://schemas.openxmlformats.org/officeDocument/2006/relationships" id="256" r:id="R8a36c1028c0c4ec8"/>
+    <p:sldId xmlns:r="http://schemas.openxmlformats.org/officeDocument/2006/relationships" id="257" r:id="R7aa032e0fddf446f"/>
+    <p:sldId xmlns:r="http://schemas.openxmlformats.org/officeDocument/2006/relationships" id="258" r:id="R4b24965b60304dbe"/>
+    <p:sldId xmlns:r="http://schemas.openxmlformats.org/officeDocument/2006/relationships" id="259" r:id="R20287407ad4d42cb"/>
+    <p:sldId xmlns:r="http://schemas.openxmlformats.org/officeDocument/2006/relationships" id="260" r:id="R9a6c82def5b04cbd"/>
+    <p:sldId xmlns:r="http://schemas.openxmlformats.org/officeDocument/2006/relationships" id="261" r:id="Rbf9bc35465c14816"/>
+    <p:sldId xmlns:r="http://schemas.openxmlformats.org/officeDocument/2006/relationships" id="262" r:id="Ra3b6f2cc869f4c97"/>
+    <p:sldId xmlns:r="http://schemas.openxmlformats.org/officeDocument/2006/relationships" id="263" r:id="R9b56aa098ffe4a66"/>
+    <p:sldId xmlns:r="http://schemas.openxmlformats.org/officeDocument/2006/relationships" id="264" r:id="R4b2abb086fe94926"/>
+    <p:sldId xmlns:r="http://schemas.openxmlformats.org/officeDocument/2006/relationships" id="265" r:id="R70f627dae64a4563"/>
+    <p:sldId xmlns:r="http://schemas.openxmlformats.org/officeDocument/2006/relationships" id="266" r:id="R024c63a134bc4009"/>
+    <p:sldId xmlns:r="http://schemas.openxmlformats.org/officeDocument/2006/relationships" id="267" r:id="R113e260e787f4a37"/>
+    <p:sldId xmlns:r="http://schemas.openxmlformats.org/officeDocument/2006/relationships" id="268" r:id="R341bbe303ecc4f17"/>
+    <p:sldId xmlns:r="http://schemas.openxmlformats.org/officeDocument/2006/relationships" id="269" r:id="Ref653a00b85a452d"/>
   </p:sldIdLst>
   <p:sldSz cx="12192000" cy="6858000"/>
   <p:notesSz cx="6858000" cy="9144000"/>
@@ -1365,7 +1365,7 @@
           <a:lstStyle xmlns:a="http://schemas.openxmlformats.org/drawingml/2006/main"/>
           <a:p xmlns:a="http://schemas.openxmlformats.org/drawingml/2006/main">
             <a:r>
-              <a:t>El quinto requisito es el precio con indicador externo. La electronica importada se cotiza en dolares y se convierte con el valor del dia que entrega mindicador.cl. Usamos la libreria requests con tiempo maximo de espera de cinco segundos. Si la API no responde, se guarda el ultimo valor conocido y el sistema lo informa y sigue funcionando: ese es el caso P17 del guion de pruebas.</a:t>
+              <a:t>El quinto requisito es el precio con indicador externo. La electronica importada se cotiza en dolares y se convierte con el valor del dia. Para no depender de un solo sitio, el servicio recorre dos proveedores: primero mindicador.cl y, si no responde, findic.cl; los dos entregan el mismo formato. Cada intento usa requests con timeout de cinco segundos. Si fallan los dos, se usa el ultimo valor guardado y el sistema lo informa: ese es el caso P17 del guion de pruebas. Cuando responde el respaldo, el sistema avisa cual uso.</a:t>
             </a:r>
           </a:p>
         </p:txBody>
@@ -1412,7 +1412,7 @@
           <p:cNvPr id="3" name="Title">
             <a:extLst xmlns:a="http://schemas.openxmlformats.org/drawingml/2006/main">
               <a:ext uri="{FF2B5EF4-FFF2-40B4-BE49-F238E27FC236}">
-                <a16:creationId xmlns:a16="http://schemas.microsoft.com/office/drawing/2014/main" id="{5FBE924C-FF17-4490-819B-5B9B401EA486}"/>
+                <a16:creationId xmlns:a16="http://schemas.microsoft.com/office/drawing/2014/main" id="{30DA725F-4855-449D-ACB2-2C5A5A29162E}"/>
               </a:ext>
             </a:extLst>
           </p:cNvPr>
@@ -1569,7 +1569,7 @@
           <p:cNvPr id="2" name="Subtitle">
             <a:extLst xmlns:a="http://schemas.openxmlformats.org/drawingml/2006/main">
               <a:ext uri="{FF2B5EF4-FFF2-40B4-BE49-F238E27FC236}">
-                <a16:creationId xmlns:a16="http://schemas.microsoft.com/office/drawing/2014/main" id="{9EEDFCEC-A5CB-4F33-91CE-4F2AB9AC082A}"/>
+                <a16:creationId xmlns:a16="http://schemas.microsoft.com/office/drawing/2014/main" id="{0FD91931-8AB8-4A2A-8B1A-F34E13205FAF}"/>
               </a:ext>
             </a:extLst>
           </p:cNvPr>
@@ -1743,7 +1743,7 @@
           <p:cNvPr id="2" name="Section title">
             <a:extLst xmlns:a="http://schemas.openxmlformats.org/drawingml/2006/main">
               <a:ext uri="{FF2B5EF4-FFF2-40B4-BE49-F238E27FC236}">
-                <a16:creationId xmlns:a16="http://schemas.microsoft.com/office/drawing/2014/main" id="{481C889D-3F8E-4C60-B52E-63B849ACCE2C}"/>
+                <a16:creationId xmlns:a16="http://schemas.microsoft.com/office/drawing/2014/main" id="{7597A882-5859-4DF2-81C0-D2D9BAA2D20F}"/>
               </a:ext>
             </a:extLst>
           </p:cNvPr>
@@ -1917,7 +1917,7 @@
           <p:cNvPr id="3" name="Title">
             <a:extLst xmlns:a="http://schemas.openxmlformats.org/drawingml/2006/main">
               <a:ext uri="{FF2B5EF4-FFF2-40B4-BE49-F238E27FC236}">
-                <a16:creationId xmlns:a16="http://schemas.microsoft.com/office/drawing/2014/main" id="{BE4FDB3C-DA7C-4E7A-AC83-392A309A43C3}"/>
+                <a16:creationId xmlns:a16="http://schemas.microsoft.com/office/drawing/2014/main" id="{C9B25B1E-6C0C-46F3-B8A7-9B291E891D98}"/>
               </a:ext>
             </a:extLst>
           </p:cNvPr>
@@ -2074,7 +2074,7 @@
           <p:cNvPr id="2" name="Body">
             <a:extLst xmlns:a="http://schemas.openxmlformats.org/drawingml/2006/main">
               <a:ext uri="{FF2B5EF4-FFF2-40B4-BE49-F238E27FC236}">
-                <a16:creationId xmlns:a16="http://schemas.microsoft.com/office/drawing/2014/main" id="{131E2379-68C5-4A1B-AC25-4115F75351E6}"/>
+                <a16:creationId xmlns:a16="http://schemas.microsoft.com/office/drawing/2014/main" id="{427DD1BA-E2F3-4EF5-9A6E-55C579EB7FB5}"/>
               </a:ext>
             </a:extLst>
           </p:cNvPr>
@@ -2248,7 +2248,7 @@
           <p:cNvPr id="4" name="Title">
             <a:extLst xmlns:a="http://schemas.openxmlformats.org/drawingml/2006/main">
               <a:ext uri="{FF2B5EF4-FFF2-40B4-BE49-F238E27FC236}">
-                <a16:creationId xmlns:a16="http://schemas.microsoft.com/office/drawing/2014/main" id="{421C2833-B2B6-4FAE-8D72-3A91AF424CF0}"/>
+                <a16:creationId xmlns:a16="http://schemas.microsoft.com/office/drawing/2014/main" id="{69319F19-0725-43E6-BB8A-4AF9B8D6468E}"/>
               </a:ext>
             </a:extLst>
           </p:cNvPr>
@@ -2405,7 +2405,7 @@
           <p:cNvPr id="2" name="Left column">
             <a:extLst xmlns:a="http://schemas.openxmlformats.org/drawingml/2006/main">
               <a:ext uri="{FF2B5EF4-FFF2-40B4-BE49-F238E27FC236}">
-                <a16:creationId xmlns:a16="http://schemas.microsoft.com/office/drawing/2014/main" id="{873F31A6-75DA-40BE-92B4-89E3DD467E83}"/>
+                <a16:creationId xmlns:a16="http://schemas.microsoft.com/office/drawing/2014/main" id="{D8D351AC-D48B-4D79-8307-1C9F031BDCB0}"/>
               </a:ext>
             </a:extLst>
           </p:cNvPr>
@@ -2562,7 +2562,7 @@
           <p:cNvPr id="3" name="Right column">
             <a:extLst xmlns:a="http://schemas.openxmlformats.org/drawingml/2006/main">
               <a:ext uri="{FF2B5EF4-FFF2-40B4-BE49-F238E27FC236}">
-                <a16:creationId xmlns:a16="http://schemas.microsoft.com/office/drawing/2014/main" id="{8B54AA5A-501C-4886-9919-08F8252A22E5}"/>
+                <a16:creationId xmlns:a16="http://schemas.microsoft.com/office/drawing/2014/main" id="{609252CD-BF1E-4768-AA31-C3643A6966B2}"/>
               </a:ext>
             </a:extLst>
           </p:cNvPr>
@@ -2736,7 +2736,7 @@
           <p:cNvPr id="3" name="Title">
             <a:extLst xmlns:a="http://schemas.openxmlformats.org/drawingml/2006/main">
               <a:ext uri="{FF2B5EF4-FFF2-40B4-BE49-F238E27FC236}">
-                <a16:creationId xmlns:a16="http://schemas.microsoft.com/office/drawing/2014/main" id="{E616B08A-864C-494F-B86F-CA7068441682}"/>
+                <a16:creationId xmlns:a16="http://schemas.microsoft.com/office/drawing/2014/main" id="{054748F7-5878-4F72-903B-CC9087356F3D}"/>
               </a:ext>
             </a:extLst>
           </p:cNvPr>
@@ -2893,7 +2893,7 @@
           <p:cNvPr id="2" name="Left column">
             <a:extLst xmlns:a="http://schemas.openxmlformats.org/drawingml/2006/main">
               <a:ext uri="{FF2B5EF4-FFF2-40B4-BE49-F238E27FC236}">
-                <a16:creationId xmlns:a16="http://schemas.microsoft.com/office/drawing/2014/main" id="{E7F28361-100F-4482-81C6-7571DBEE35CD}"/>
+                <a16:creationId xmlns:a16="http://schemas.microsoft.com/office/drawing/2014/main" id="{942E23B5-63CB-4EFA-982F-181E6EEA9861}"/>
               </a:ext>
             </a:extLst>
           </p:cNvPr>
@@ -3088,12 +3088,12 @@
   </p:cSld>
   <p:clrMap bg1="lt1" tx1="dk1" bg2="lt2" tx2="dk2" accent1="accent1" accent2="accent2" accent3="accent3" accent4="accent4" accent5="accent5" accent6="accent6" hlink="hlink" folHlink="folHlink"/>
   <p:sldLayoutIdLst>
-    <p:sldLayoutId xmlns:r="http://schemas.openxmlformats.org/officeDocument/2006/relationships" id="2147483649" r:id="R4e67a0e86e5b4de8"/>
-    <p:sldLayoutId xmlns:r="http://schemas.openxmlformats.org/officeDocument/2006/relationships" id="2147483650" r:id="Rae0e6633ec124b08"/>
-    <p:sldLayoutId xmlns:r="http://schemas.openxmlformats.org/officeDocument/2006/relationships" id="2147483651" r:id="Ra6b89a3fc41d4340"/>
-    <p:sldLayoutId xmlns:r="http://schemas.openxmlformats.org/officeDocument/2006/relationships" id="2147483652" r:id="R143425fdb4bb4c58"/>
-    <p:sldLayoutId xmlns:r="http://schemas.openxmlformats.org/officeDocument/2006/relationships" id="2147483653" r:id="R13e5d204dde94e19"/>
-    <p:sldLayoutId xmlns:r="http://schemas.openxmlformats.org/officeDocument/2006/relationships" id="2147483654" r:id="Rf5a2872329cf41a1"/>
+    <p:sldLayoutId xmlns:r="http://schemas.openxmlformats.org/officeDocument/2006/relationships" id="2147483649" r:id="R4c899968489c49f9"/>
+    <p:sldLayoutId xmlns:r="http://schemas.openxmlformats.org/officeDocument/2006/relationships" id="2147483650" r:id="Rd6417326b3bb42b1"/>
+    <p:sldLayoutId xmlns:r="http://schemas.openxmlformats.org/officeDocument/2006/relationships" id="2147483651" r:id="Rd0111f850d4540c5"/>
+    <p:sldLayoutId xmlns:r="http://schemas.openxmlformats.org/officeDocument/2006/relationships" id="2147483652" r:id="R3d12fb78829446bb"/>
+    <p:sldLayoutId xmlns:r="http://schemas.openxmlformats.org/officeDocument/2006/relationships" id="2147483653" r:id="Rd0242da2d3594b5c"/>
+    <p:sldLayoutId xmlns:r="http://schemas.openxmlformats.org/officeDocument/2006/relationships" id="2147483654" r:id="R1f61f65f0566498f"/>
   </p:sldLayoutIdLst>
   <p:txStyles>
     <p:titleStyle>
@@ -3644,7 +3644,7 @@
           <p:cNvPr id="7" name="">
             <a:extLst xmlns:a="http://schemas.openxmlformats.org/drawingml/2006/main">
               <a:ext uri="{FF2B5EF4-FFF2-40B4-BE49-F238E27FC236}">
-                <a16:creationId xmlns:a16="http://schemas.microsoft.com/office/drawing/2014/main" id="{8C2CEC37-C16D-4422-A133-F11CAFF9A072}"/>
+                <a16:creationId xmlns:a16="http://schemas.microsoft.com/office/drawing/2014/main" id="{D4ADA0F6-7F10-46FC-A9F8-889A224BCADF}"/>
               </a:ext>
             </a:extLst>
           </p:cNvPr>
@@ -3706,7 +3706,7 @@
           <p:cNvPr id="2" name="">
             <a:extLst xmlns:a="http://schemas.openxmlformats.org/drawingml/2006/main">
               <a:ext uri="{FF2B5EF4-FFF2-40B4-BE49-F238E27FC236}">
-                <a16:creationId xmlns:a16="http://schemas.microsoft.com/office/drawing/2014/main" id="{639B8DD7-002D-467C-813D-620C43F8A9FC}"/>
+                <a16:creationId xmlns:a16="http://schemas.microsoft.com/office/drawing/2014/main" id="{9CED6873-1FA9-4E99-ABEA-A27345B22512}"/>
               </a:ext>
             </a:extLst>
           </p:cNvPr>
@@ -3768,7 +3768,7 @@
           <p:cNvPr id="3" name="">
             <a:extLst xmlns:a="http://schemas.openxmlformats.org/drawingml/2006/main">
               <a:ext uri="{FF2B5EF4-FFF2-40B4-BE49-F238E27FC236}">
-                <a16:creationId xmlns:a16="http://schemas.microsoft.com/office/drawing/2014/main" id="{1518D75F-023F-45B8-98E4-8CAA272F1543}"/>
+                <a16:creationId xmlns:a16="http://schemas.microsoft.com/office/drawing/2014/main" id="{5AE5A725-318D-4528-80BA-E85BA2400894}"/>
               </a:ext>
             </a:extLst>
           </p:cNvPr>
@@ -3830,7 +3830,7 @@
           <p:cNvPr id="4" name="">
             <a:extLst xmlns:a="http://schemas.openxmlformats.org/drawingml/2006/main">
               <a:ext uri="{FF2B5EF4-FFF2-40B4-BE49-F238E27FC236}">
-                <a16:creationId xmlns:a16="http://schemas.microsoft.com/office/drawing/2014/main" id="{D96B28F7-0BD9-4728-A0A0-2559F9823EEA}"/>
+                <a16:creationId xmlns:a16="http://schemas.microsoft.com/office/drawing/2014/main" id="{6E0570C3-1C38-465A-8E93-9E8124F545C8}"/>
               </a:ext>
             </a:extLst>
           </p:cNvPr>
@@ -3861,7 +3861,7 @@
           <p:cNvPr id="5" name="">
             <a:extLst xmlns:a="http://schemas.openxmlformats.org/drawingml/2006/main">
               <a:ext uri="{FF2B5EF4-FFF2-40B4-BE49-F238E27FC236}">
-                <a16:creationId xmlns:a16="http://schemas.microsoft.com/office/drawing/2014/main" id="{B542EE2A-F479-4708-8266-BD82CFFA16E8}"/>
+                <a16:creationId xmlns:a16="http://schemas.microsoft.com/office/drawing/2014/main" id="{AE4E2C2D-A26A-4526-8A66-46EABD90B1F3}"/>
               </a:ext>
             </a:extLst>
           </p:cNvPr>
@@ -3923,7 +3923,7 @@
           <p:cNvPr id="6" name="">
             <a:extLst xmlns:a="http://schemas.openxmlformats.org/drawingml/2006/main">
               <a:ext uri="{FF2B5EF4-FFF2-40B4-BE49-F238E27FC236}">
-                <a16:creationId xmlns:a16="http://schemas.microsoft.com/office/drawing/2014/main" id="{511B4038-01E8-436C-869D-25ADFC358BEB}"/>
+                <a16:creationId xmlns:a16="http://schemas.microsoft.com/office/drawing/2014/main" id="{BBAB5AE9-9FD0-453F-89AA-CE448566F806}"/>
               </a:ext>
             </a:extLst>
           </p:cNvPr>
@@ -3983,7 +3983,7 @@
     </p:spTree>
     <p:extLst>
       <p:ext uri="{BB962C8B-B14F-4D97-AF65-F5344CB8AC3E}">
-        <p14:creationId xmlns:p14="http://schemas.microsoft.com/office/powerpoint/2010/main" val="1461063376"/>
+        <p14:creationId xmlns:p14="http://schemas.microsoft.com/office/powerpoint/2010/main" val="1111278857"/>
       </p:ext>
     </p:extLst>
   </p:cSld>
@@ -4007,7 +4007,7 @@
           <p:cNvPr id="5" name="">
             <a:extLst xmlns:a="http://schemas.openxmlformats.org/drawingml/2006/main">
               <a:ext uri="{FF2B5EF4-FFF2-40B4-BE49-F238E27FC236}">
-                <a16:creationId xmlns:a16="http://schemas.microsoft.com/office/drawing/2014/main" id="{BDA6B755-D58D-4CBD-B27D-82AFE6141773}"/>
+                <a16:creationId xmlns:a16="http://schemas.microsoft.com/office/drawing/2014/main" id="{5F043535-5B26-4876-BCF9-FA75CE3BB6FE}"/>
               </a:ext>
             </a:extLst>
           </p:cNvPr>
@@ -4069,7 +4069,7 @@
           <p:cNvPr id="2" name="">
             <a:extLst xmlns:a="http://schemas.openxmlformats.org/drawingml/2006/main">
               <a:ext uri="{FF2B5EF4-FFF2-40B4-BE49-F238E27FC236}">
-                <a16:creationId xmlns:a16="http://schemas.microsoft.com/office/drawing/2014/main" id="{EDD2734C-930D-4369-9C38-BC4BECDA1BFC}"/>
+                <a16:creationId xmlns:a16="http://schemas.microsoft.com/office/drawing/2014/main" id="{A86D305C-8C71-4899-86B6-79AB4FFF6CB3}"/>
               </a:ext>
             </a:extLst>
           </p:cNvPr>
@@ -4131,7 +4131,7 @@
           <p:cNvPr id="3" name="">
             <a:extLst xmlns:a="http://schemas.openxmlformats.org/drawingml/2006/main">
               <a:ext uri="{FF2B5EF4-FFF2-40B4-BE49-F238E27FC236}">
-                <a16:creationId xmlns:a16="http://schemas.microsoft.com/office/drawing/2014/main" id="{F1529EAE-7C6A-4FAF-83B5-6F3E874BB4DC}"/>
+                <a16:creationId xmlns:a16="http://schemas.microsoft.com/office/drawing/2014/main" id="{7E8F7421-8CC2-4661-AAE8-B0E032F120BB}"/>
               </a:ext>
             </a:extLst>
           </p:cNvPr>
@@ -4193,7 +4193,7 @@
           <p:cNvPr id="4" name="">
             <a:extLst xmlns:a="http://schemas.openxmlformats.org/drawingml/2006/main">
               <a:ext uri="{FF2B5EF4-FFF2-40B4-BE49-F238E27FC236}">
-                <a16:creationId xmlns:a16="http://schemas.microsoft.com/office/drawing/2014/main" id="{EC45A721-7990-4C46-8869-2D2F1D449D66}"/>
+                <a16:creationId xmlns:a16="http://schemas.microsoft.com/office/drawing/2014/main" id="{C7999EAA-9168-4A8C-A40E-02597F333AF0}"/>
               </a:ext>
             </a:extLst>
           </p:cNvPr>
@@ -4675,7 +4675,7 @@
     </p:spTree>
     <p:extLst>
       <p:ext uri="{BB962C8B-B14F-4D97-AF65-F5344CB8AC3E}">
-        <p14:creationId xmlns:p14="http://schemas.microsoft.com/office/powerpoint/2010/main" val="1126271231"/>
+        <p14:creationId xmlns:p14="http://schemas.microsoft.com/office/powerpoint/2010/main" val="1625205005"/>
       </p:ext>
     </p:extLst>
   </p:cSld>
@@ -4699,7 +4699,7 @@
           <p:cNvPr id="5" name="">
             <a:extLst xmlns:a="http://schemas.openxmlformats.org/drawingml/2006/main">
               <a:ext uri="{FF2B5EF4-FFF2-40B4-BE49-F238E27FC236}">
-                <a16:creationId xmlns:a16="http://schemas.microsoft.com/office/drawing/2014/main" id="{02199E01-4F76-46A3-B02B-92B7EA83CAF1}"/>
+                <a16:creationId xmlns:a16="http://schemas.microsoft.com/office/drawing/2014/main" id="{F22AF414-6048-46F9-8C91-4ED931AC5339}"/>
               </a:ext>
             </a:extLst>
           </p:cNvPr>
@@ -4761,7 +4761,7 @@
           <p:cNvPr id="2" name="">
             <a:extLst xmlns:a="http://schemas.openxmlformats.org/drawingml/2006/main">
               <a:ext uri="{FF2B5EF4-FFF2-40B4-BE49-F238E27FC236}">
-                <a16:creationId xmlns:a16="http://schemas.microsoft.com/office/drawing/2014/main" id="{FA6017B2-E01C-4888-9761-EC78762B356F}"/>
+                <a16:creationId xmlns:a16="http://schemas.microsoft.com/office/drawing/2014/main" id="{694F99C0-970E-4E6C-94AA-D4E934CEC88F}"/>
               </a:ext>
             </a:extLst>
           </p:cNvPr>
@@ -4823,7 +4823,7 @@
           <p:cNvPr id="3" name="">
             <a:extLst xmlns:a="http://schemas.openxmlformats.org/drawingml/2006/main">
               <a:ext uri="{FF2B5EF4-FFF2-40B4-BE49-F238E27FC236}">
-                <a16:creationId xmlns:a16="http://schemas.microsoft.com/office/drawing/2014/main" id="{69A783BC-405E-4D5E-81B2-DE361F744DA9}"/>
+                <a16:creationId xmlns:a16="http://schemas.microsoft.com/office/drawing/2014/main" id="{6657DDA9-1D73-4458-9748-6AD8B5D6CBF4}"/>
               </a:ext>
             </a:extLst>
           </p:cNvPr>
@@ -4885,7 +4885,7 @@
           <p:cNvPr id="4" name="">
             <a:extLst xmlns:a="http://schemas.openxmlformats.org/drawingml/2006/main">
               <a:ext uri="{FF2B5EF4-FFF2-40B4-BE49-F238E27FC236}">
-                <a16:creationId xmlns:a16="http://schemas.microsoft.com/office/drawing/2014/main" id="{42300918-BA2C-4DE8-938B-68EAF87953DD}"/>
+                <a16:creationId xmlns:a16="http://schemas.microsoft.com/office/drawing/2014/main" id="{EFF91BC3-AF08-4CDF-AB60-DE500CC88350}"/>
               </a:ext>
             </a:extLst>
           </p:cNvPr>
@@ -5367,7 +5367,7 @@
     </p:spTree>
     <p:extLst>
       <p:ext uri="{BB962C8B-B14F-4D97-AF65-F5344CB8AC3E}">
-        <p14:creationId xmlns:p14="http://schemas.microsoft.com/office/powerpoint/2010/main" val="47662743"/>
+        <p14:creationId xmlns:p14="http://schemas.microsoft.com/office/powerpoint/2010/main" val="901221273"/>
       </p:ext>
     </p:extLst>
   </p:cSld>
@@ -5391,7 +5391,7 @@
           <p:cNvPr id="11" name="">
             <a:extLst xmlns:a="http://schemas.openxmlformats.org/drawingml/2006/main">
               <a:ext uri="{FF2B5EF4-FFF2-40B4-BE49-F238E27FC236}">
-                <a16:creationId xmlns:a16="http://schemas.microsoft.com/office/drawing/2014/main" id="{DC94CF37-5E59-4BCB-982C-611F53FAF36A}"/>
+                <a16:creationId xmlns:a16="http://schemas.microsoft.com/office/drawing/2014/main" id="{42B08D86-90DD-444C-9DE4-427C9CF63CD4}"/>
               </a:ext>
             </a:extLst>
           </p:cNvPr>
@@ -5453,7 +5453,7 @@
           <p:cNvPr id="2" name="">
             <a:extLst xmlns:a="http://schemas.openxmlformats.org/drawingml/2006/main">
               <a:ext uri="{FF2B5EF4-FFF2-40B4-BE49-F238E27FC236}">
-                <a16:creationId xmlns:a16="http://schemas.microsoft.com/office/drawing/2014/main" id="{497062E9-DAFF-4DD5-88B2-BC91A68B32F5}"/>
+                <a16:creationId xmlns:a16="http://schemas.microsoft.com/office/drawing/2014/main" id="{24486D12-C07C-47A6-86E8-74B1FC4BE39B}"/>
               </a:ext>
             </a:extLst>
           </p:cNvPr>
@@ -5515,7 +5515,7 @@
           <p:cNvPr id="3" name="">
             <a:extLst xmlns:a="http://schemas.openxmlformats.org/drawingml/2006/main">
               <a:ext uri="{FF2B5EF4-FFF2-40B4-BE49-F238E27FC236}">
-                <a16:creationId xmlns:a16="http://schemas.microsoft.com/office/drawing/2014/main" id="{52E1B1AD-8AC7-4C34-94FF-A60A1D89442B}"/>
+                <a16:creationId xmlns:a16="http://schemas.microsoft.com/office/drawing/2014/main" id="{6C5C276C-D533-46F7-8738-385934AF30CC}"/>
               </a:ext>
             </a:extLst>
           </p:cNvPr>
@@ -5577,7 +5577,7 @@
           <p:cNvPr id="4" name="">
             <a:extLst xmlns:a="http://schemas.openxmlformats.org/drawingml/2006/main">
               <a:ext uri="{FF2B5EF4-FFF2-40B4-BE49-F238E27FC236}">
-                <a16:creationId xmlns:a16="http://schemas.microsoft.com/office/drawing/2014/main" id="{4217A2F4-E439-4EF3-B8D5-6D4E2F6347F8}"/>
+                <a16:creationId xmlns:a16="http://schemas.microsoft.com/office/drawing/2014/main" id="{FBD49034-0551-4ED3-B3D7-5A26FA8392AF}"/>
               </a:ext>
             </a:extLst>
           </p:cNvPr>
@@ -5612,7 +5612,7 @@
           <p:cNvPr id="5" name="">
             <a:extLst xmlns:a="http://schemas.openxmlformats.org/drawingml/2006/main">
               <a:ext uri="{FF2B5EF4-FFF2-40B4-BE49-F238E27FC236}">
-                <a16:creationId xmlns:a16="http://schemas.microsoft.com/office/drawing/2014/main" id="{33ABBEA7-15E1-4BC1-ADAE-60747CE7006D}"/>
+                <a16:creationId xmlns:a16="http://schemas.microsoft.com/office/drawing/2014/main" id="{233E1A68-D802-464C-B377-93E4FE0DC561}"/>
               </a:ext>
             </a:extLst>
           </p:cNvPr>
@@ -5674,7 +5674,7 @@
           <p:cNvPr id="6" name="">
             <a:extLst xmlns:a="http://schemas.openxmlformats.org/drawingml/2006/main">
               <a:ext uri="{FF2B5EF4-FFF2-40B4-BE49-F238E27FC236}">
-                <a16:creationId xmlns:a16="http://schemas.microsoft.com/office/drawing/2014/main" id="{A945445A-7B3E-4C5F-8232-AE5E7824EA1A}"/>
+                <a16:creationId xmlns:a16="http://schemas.microsoft.com/office/drawing/2014/main" id="{C79AC3A4-9649-4081-9685-D48B17378A01}"/>
               </a:ext>
             </a:extLst>
           </p:cNvPr>
@@ -5799,7 +5799,7 @@
           <p:cNvPr id="7" name="">
             <a:extLst xmlns:a="http://schemas.openxmlformats.org/drawingml/2006/main">
               <a:ext uri="{FF2B5EF4-FFF2-40B4-BE49-F238E27FC236}">
-                <a16:creationId xmlns:a16="http://schemas.microsoft.com/office/drawing/2014/main" id="{F4399AB1-BAFF-412B-A66D-75797D82BC09}"/>
+                <a16:creationId xmlns:a16="http://schemas.microsoft.com/office/drawing/2014/main" id="{5BE06741-3DD1-4F27-A253-B92E293D6208}"/>
               </a:ext>
             </a:extLst>
           </p:cNvPr>
@@ -5834,7 +5834,7 @@
           <p:cNvPr id="8" name="">
             <a:extLst xmlns:a="http://schemas.openxmlformats.org/drawingml/2006/main">
               <a:ext uri="{FF2B5EF4-FFF2-40B4-BE49-F238E27FC236}">
-                <a16:creationId xmlns:a16="http://schemas.microsoft.com/office/drawing/2014/main" id="{4006749F-C2BD-4B70-8A1E-5F99E24A98E1}"/>
+                <a16:creationId xmlns:a16="http://schemas.microsoft.com/office/drawing/2014/main" id="{873DB777-D272-4D9D-A6C9-F7389219D5AF}"/>
               </a:ext>
             </a:extLst>
           </p:cNvPr>
@@ -5896,7 +5896,7 @@
           <p:cNvPr id="9" name="">
             <a:extLst xmlns:a="http://schemas.openxmlformats.org/drawingml/2006/main">
               <a:ext uri="{FF2B5EF4-FFF2-40B4-BE49-F238E27FC236}">
-                <a16:creationId xmlns:a16="http://schemas.microsoft.com/office/drawing/2014/main" id="{5B1BB6B9-65E7-4A35-BE0E-45480228FFD6}"/>
+                <a16:creationId xmlns:a16="http://schemas.microsoft.com/office/drawing/2014/main" id="{F6BCFEF0-D72A-4B47-8A04-213C2F7C002C}"/>
               </a:ext>
             </a:extLst>
           </p:cNvPr>
@@ -6042,7 +6042,7 @@
           <p:cNvPr id="10" name="">
             <a:extLst xmlns:a="http://schemas.openxmlformats.org/drawingml/2006/main">
               <a:ext uri="{FF2B5EF4-FFF2-40B4-BE49-F238E27FC236}">
-                <a16:creationId xmlns:a16="http://schemas.microsoft.com/office/drawing/2014/main" id="{09E4E00C-DAB8-480D-980A-62E7E98C4958}"/>
+                <a16:creationId xmlns:a16="http://schemas.microsoft.com/office/drawing/2014/main" id="{AECA3594-7C3C-471D-A3F5-DCC1A2DDB4E8}"/>
               </a:ext>
             </a:extLst>
           </p:cNvPr>
@@ -6524,7 +6524,7 @@
     </p:spTree>
     <p:extLst>
       <p:ext uri="{BB962C8B-B14F-4D97-AF65-F5344CB8AC3E}">
-        <p14:creationId xmlns:p14="http://schemas.microsoft.com/office/powerpoint/2010/main" val="1167863304"/>
+        <p14:creationId xmlns:p14="http://schemas.microsoft.com/office/powerpoint/2010/main" val="855408334"/>
       </p:ext>
     </p:extLst>
   </p:cSld>
@@ -6548,7 +6548,7 @@
           <p:cNvPr id="5" name="">
             <a:extLst xmlns:a="http://schemas.openxmlformats.org/drawingml/2006/main">
               <a:ext uri="{FF2B5EF4-FFF2-40B4-BE49-F238E27FC236}">
-                <a16:creationId xmlns:a16="http://schemas.microsoft.com/office/drawing/2014/main" id="{D0C3F400-B751-4A61-B1FE-EE1DD27E6B7E}"/>
+                <a16:creationId xmlns:a16="http://schemas.microsoft.com/office/drawing/2014/main" id="{0B4D8FBC-8F89-4EE3-9D74-139D6506DAD0}"/>
               </a:ext>
             </a:extLst>
           </p:cNvPr>
@@ -6610,7 +6610,7 @@
           <p:cNvPr id="2" name="">
             <a:extLst xmlns:a="http://schemas.openxmlformats.org/drawingml/2006/main">
               <a:ext uri="{FF2B5EF4-FFF2-40B4-BE49-F238E27FC236}">
-                <a16:creationId xmlns:a16="http://schemas.microsoft.com/office/drawing/2014/main" id="{6E116802-7E95-4E83-A5C7-BEF935B3A517}"/>
+                <a16:creationId xmlns:a16="http://schemas.microsoft.com/office/drawing/2014/main" id="{1966B235-CEB4-459D-AD50-3C151CC89718}"/>
               </a:ext>
             </a:extLst>
           </p:cNvPr>
@@ -6672,7 +6672,7 @@
           <p:cNvPr id="3" name="">
             <a:extLst xmlns:a="http://schemas.openxmlformats.org/drawingml/2006/main">
               <a:ext uri="{FF2B5EF4-FFF2-40B4-BE49-F238E27FC236}">
-                <a16:creationId xmlns:a16="http://schemas.microsoft.com/office/drawing/2014/main" id="{0CAED00B-B0F9-4984-8A94-C841A27D8131}"/>
+                <a16:creationId xmlns:a16="http://schemas.microsoft.com/office/drawing/2014/main" id="{FBD1846D-5ED8-40D8-ADAE-E3F7A9712054}"/>
               </a:ext>
             </a:extLst>
           </p:cNvPr>
@@ -6734,7 +6734,7 @@
           <p:cNvPr id="4" name="">
             <a:extLst xmlns:a="http://schemas.openxmlformats.org/drawingml/2006/main">
               <a:ext uri="{FF2B5EF4-FFF2-40B4-BE49-F238E27FC236}">
-                <a16:creationId xmlns:a16="http://schemas.microsoft.com/office/drawing/2014/main" id="{2E54E072-A2A5-46A3-925A-92E25A5EBE93}"/>
+                <a16:creationId xmlns:a16="http://schemas.microsoft.com/office/drawing/2014/main" id="{5368A3E5-5AEC-45B0-92D4-1D4DE4AF921A}"/>
               </a:ext>
             </a:extLst>
           </p:cNvPr>
@@ -7086,7 +7086,7 @@
     </p:spTree>
     <p:extLst>
       <p:ext uri="{BB962C8B-B14F-4D97-AF65-F5344CB8AC3E}">
-        <p14:creationId xmlns:p14="http://schemas.microsoft.com/office/powerpoint/2010/main" val="292594860"/>
+        <p14:creationId xmlns:p14="http://schemas.microsoft.com/office/powerpoint/2010/main" val="173034522"/>
       </p:ext>
     </p:extLst>
   </p:cSld>
@@ -7110,7 +7110,7 @@
           <p:cNvPr id="14" name="">
             <a:extLst xmlns:a="http://schemas.openxmlformats.org/drawingml/2006/main">
               <a:ext uri="{FF2B5EF4-FFF2-40B4-BE49-F238E27FC236}">
-                <a16:creationId xmlns:a16="http://schemas.microsoft.com/office/drawing/2014/main" id="{2AE85383-158C-431D-8AD5-746D81E74AD1}"/>
+                <a16:creationId xmlns:a16="http://schemas.microsoft.com/office/drawing/2014/main" id="{05F206CB-2318-4989-BD86-33DD3047EE96}"/>
               </a:ext>
             </a:extLst>
           </p:cNvPr>
@@ -7172,7 +7172,7 @@
           <p:cNvPr id="2" name="">
             <a:extLst xmlns:a="http://schemas.openxmlformats.org/drawingml/2006/main">
               <a:ext uri="{FF2B5EF4-FFF2-40B4-BE49-F238E27FC236}">
-                <a16:creationId xmlns:a16="http://schemas.microsoft.com/office/drawing/2014/main" id="{F2DA36A1-4B08-49C2-A122-9EEDA10E5590}"/>
+                <a16:creationId xmlns:a16="http://schemas.microsoft.com/office/drawing/2014/main" id="{16EB1FB3-A633-4ACF-B9EA-12C92191C531}"/>
               </a:ext>
             </a:extLst>
           </p:cNvPr>
@@ -7234,7 +7234,7 @@
           <p:cNvPr id="3" name="">
             <a:extLst xmlns:a="http://schemas.openxmlformats.org/drawingml/2006/main">
               <a:ext uri="{FF2B5EF4-FFF2-40B4-BE49-F238E27FC236}">
-                <a16:creationId xmlns:a16="http://schemas.microsoft.com/office/drawing/2014/main" id="{D02F5335-C766-4CEB-BEFB-7045C15BD2C4}"/>
+                <a16:creationId xmlns:a16="http://schemas.microsoft.com/office/drawing/2014/main" id="{138264B0-A9F1-4436-9A34-4351672DE2A5}"/>
               </a:ext>
             </a:extLst>
           </p:cNvPr>
@@ -7296,7 +7296,7 @@
           <p:cNvPr id="4" name="">
             <a:extLst xmlns:a="http://schemas.openxmlformats.org/drawingml/2006/main">
               <a:ext uri="{FF2B5EF4-FFF2-40B4-BE49-F238E27FC236}">
-                <a16:creationId xmlns:a16="http://schemas.microsoft.com/office/drawing/2014/main" id="{5A770D1F-4AB5-401B-88CC-18B6E882149F}"/>
+                <a16:creationId xmlns:a16="http://schemas.microsoft.com/office/drawing/2014/main" id="{0BA646E9-696A-4883-A0E0-B346627C8F4B}"/>
               </a:ext>
             </a:extLst>
           </p:cNvPr>
@@ -7331,7 +7331,7 @@
           <p:cNvPr id="5" name="">
             <a:extLst xmlns:a="http://schemas.openxmlformats.org/drawingml/2006/main">
               <a:ext uri="{FF2B5EF4-FFF2-40B4-BE49-F238E27FC236}">
-                <a16:creationId xmlns:a16="http://schemas.microsoft.com/office/drawing/2014/main" id="{02F6F09D-66AF-4214-B78C-90371FC0BDC9}"/>
+                <a16:creationId xmlns:a16="http://schemas.microsoft.com/office/drawing/2014/main" id="{B2E89899-8D21-4394-93A1-D1C33F3E6B73}"/>
               </a:ext>
             </a:extLst>
           </p:cNvPr>
@@ -7393,7 +7393,7 @@
           <p:cNvPr id="6" name="">
             <a:extLst xmlns:a="http://schemas.openxmlformats.org/drawingml/2006/main">
               <a:ext uri="{FF2B5EF4-FFF2-40B4-BE49-F238E27FC236}">
-                <a16:creationId xmlns:a16="http://schemas.microsoft.com/office/drawing/2014/main" id="{36CF3409-3925-4C68-9C51-1FAB123B3FE8}"/>
+                <a16:creationId xmlns:a16="http://schemas.microsoft.com/office/drawing/2014/main" id="{C06D9538-D238-4F0F-95BF-970BB0A94524}"/>
               </a:ext>
             </a:extLst>
           </p:cNvPr>
@@ -7455,7 +7455,7 @@
           <p:cNvPr id="7" name="">
             <a:extLst xmlns:a="http://schemas.openxmlformats.org/drawingml/2006/main">
               <a:ext uri="{FF2B5EF4-FFF2-40B4-BE49-F238E27FC236}">
-                <a16:creationId xmlns:a16="http://schemas.microsoft.com/office/drawing/2014/main" id="{5E596E20-1D59-4584-87F0-DBA2B0341D96}"/>
+                <a16:creationId xmlns:a16="http://schemas.microsoft.com/office/drawing/2014/main" id="{973FAD0D-0190-4D0C-9B19-E77141FA763A}"/>
               </a:ext>
             </a:extLst>
           </p:cNvPr>
@@ -7517,7 +7517,7 @@
           <p:cNvPr id="8" name="">
             <a:extLst xmlns:a="http://schemas.openxmlformats.org/drawingml/2006/main">
               <a:ext uri="{FF2B5EF4-FFF2-40B4-BE49-F238E27FC236}">
-                <a16:creationId xmlns:a16="http://schemas.microsoft.com/office/drawing/2014/main" id="{ECECBE66-9175-43FB-AA89-58FF171B8401}"/>
+                <a16:creationId xmlns:a16="http://schemas.microsoft.com/office/drawing/2014/main" id="{140CD56A-8F6D-4138-A68F-D0BE4B917402}"/>
               </a:ext>
             </a:extLst>
           </p:cNvPr>
@@ -7552,7 +7552,7 @@
           <p:cNvPr id="9" name="">
             <a:extLst xmlns:a="http://schemas.openxmlformats.org/drawingml/2006/main">
               <a:ext uri="{FF2B5EF4-FFF2-40B4-BE49-F238E27FC236}">
-                <a16:creationId xmlns:a16="http://schemas.microsoft.com/office/drawing/2014/main" id="{00B8FB72-9111-4B2A-B54E-2CD76E0B45E5}"/>
+                <a16:creationId xmlns:a16="http://schemas.microsoft.com/office/drawing/2014/main" id="{0B4B5107-40BD-45CF-B826-B6FF7CDF43EF}"/>
               </a:ext>
             </a:extLst>
           </p:cNvPr>
@@ -7614,7 +7614,7 @@
           <p:cNvPr id="10" name="">
             <a:extLst xmlns:a="http://schemas.openxmlformats.org/drawingml/2006/main">
               <a:ext uri="{FF2B5EF4-FFF2-40B4-BE49-F238E27FC236}">
-                <a16:creationId xmlns:a16="http://schemas.microsoft.com/office/drawing/2014/main" id="{B4E9ECC5-D857-4D3F-9824-4698BC26BE59}"/>
+                <a16:creationId xmlns:a16="http://schemas.microsoft.com/office/drawing/2014/main" id="{20F71DE2-4B00-4EA0-874C-85B914000996}"/>
               </a:ext>
             </a:extLst>
           </p:cNvPr>
@@ -7676,7 +7676,7 @@
           <p:cNvPr id="11" name="">
             <a:extLst xmlns:a="http://schemas.openxmlformats.org/drawingml/2006/main">
               <a:ext uri="{FF2B5EF4-FFF2-40B4-BE49-F238E27FC236}">
-                <a16:creationId xmlns:a16="http://schemas.microsoft.com/office/drawing/2014/main" id="{6AB51473-74C6-4906-A3A2-00F6F685D20D}"/>
+                <a16:creationId xmlns:a16="http://schemas.microsoft.com/office/drawing/2014/main" id="{AD64C5D1-8C7A-4A3A-935B-5B5AA5377FEE}"/>
               </a:ext>
             </a:extLst>
           </p:cNvPr>
@@ -7738,7 +7738,7 @@
           <p:cNvPr id="12" name="">
             <a:extLst xmlns:a="http://schemas.openxmlformats.org/drawingml/2006/main">
               <a:ext uri="{FF2B5EF4-FFF2-40B4-BE49-F238E27FC236}">
-                <a16:creationId xmlns:a16="http://schemas.microsoft.com/office/drawing/2014/main" id="{617ECE28-436D-4E97-8429-A26A066579D0}"/>
+                <a16:creationId xmlns:a16="http://schemas.microsoft.com/office/drawing/2014/main" id="{549F399F-0770-4FC0-A9B2-7F9C00858BFC}"/>
               </a:ext>
             </a:extLst>
           </p:cNvPr>
@@ -7800,7 +7800,7 @@
           <p:cNvPr id="13" name="">
             <a:extLst xmlns:a="http://schemas.openxmlformats.org/drawingml/2006/main">
               <a:ext uri="{FF2B5EF4-FFF2-40B4-BE49-F238E27FC236}">
-                <a16:creationId xmlns:a16="http://schemas.microsoft.com/office/drawing/2014/main" id="{4627B16F-23FB-4132-B9BA-F53890063410}"/>
+                <a16:creationId xmlns:a16="http://schemas.microsoft.com/office/drawing/2014/main" id="{7BA1CF42-EE55-42D3-8F51-3CC4D7540F4E}"/>
               </a:ext>
             </a:extLst>
           </p:cNvPr>
@@ -7860,7 +7860,7 @@
     </p:spTree>
     <p:extLst>
       <p:ext uri="{BB962C8B-B14F-4D97-AF65-F5344CB8AC3E}">
-        <p14:creationId xmlns:p14="http://schemas.microsoft.com/office/powerpoint/2010/main" val="1361424138"/>
+        <p14:creationId xmlns:p14="http://schemas.microsoft.com/office/powerpoint/2010/main" val="140897121"/>
       </p:ext>
     </p:extLst>
   </p:cSld>
@@ -7884,7 +7884,7 @@
           <p:cNvPr id="16" name="">
             <a:extLst xmlns:a="http://schemas.openxmlformats.org/drawingml/2006/main">
               <a:ext uri="{FF2B5EF4-FFF2-40B4-BE49-F238E27FC236}">
-                <a16:creationId xmlns:a16="http://schemas.microsoft.com/office/drawing/2014/main" id="{7B7FAB0C-411F-4E6C-9557-B5D2E9F5496D}"/>
+                <a16:creationId xmlns:a16="http://schemas.microsoft.com/office/drawing/2014/main" id="{4C37BC24-2BD5-4EBA-846B-F7E2B1AE3009}"/>
               </a:ext>
             </a:extLst>
           </p:cNvPr>
@@ -7946,7 +7946,7 @@
           <p:cNvPr id="2" name="">
             <a:extLst xmlns:a="http://schemas.openxmlformats.org/drawingml/2006/main">
               <a:ext uri="{FF2B5EF4-FFF2-40B4-BE49-F238E27FC236}">
-                <a16:creationId xmlns:a16="http://schemas.microsoft.com/office/drawing/2014/main" id="{F83FFB27-9CC0-4D73-B4A9-27071356F1E5}"/>
+                <a16:creationId xmlns:a16="http://schemas.microsoft.com/office/drawing/2014/main" id="{05DFC9D4-5967-4E96-8A7A-CCDD835E7FA0}"/>
               </a:ext>
             </a:extLst>
           </p:cNvPr>
@@ -8008,7 +8008,7 @@
           <p:cNvPr id="3" name="">
             <a:extLst xmlns:a="http://schemas.openxmlformats.org/drawingml/2006/main">
               <a:ext uri="{FF2B5EF4-FFF2-40B4-BE49-F238E27FC236}">
-                <a16:creationId xmlns:a16="http://schemas.microsoft.com/office/drawing/2014/main" id="{4C0A9953-CB34-4201-9343-0BB239B17095}"/>
+                <a16:creationId xmlns:a16="http://schemas.microsoft.com/office/drawing/2014/main" id="{3AB66DCF-49E1-4618-8F40-4A1A575EBCC4}"/>
               </a:ext>
             </a:extLst>
           </p:cNvPr>
@@ -8070,7 +8070,7 @@
           <p:cNvPr id="4" name="">
             <a:extLst xmlns:a="http://schemas.openxmlformats.org/drawingml/2006/main">
               <a:ext uri="{FF2B5EF4-FFF2-40B4-BE49-F238E27FC236}">
-                <a16:creationId xmlns:a16="http://schemas.microsoft.com/office/drawing/2014/main" id="{530543B5-4320-4C4E-BE86-43175B030E76}"/>
+                <a16:creationId xmlns:a16="http://schemas.microsoft.com/office/drawing/2014/main" id="{73711308-7911-431B-86C2-620EB9F4D86E}"/>
               </a:ext>
             </a:extLst>
           </p:cNvPr>
@@ -8112,7 +8112,7 @@
           <p:cNvPr id="5" name="">
             <a:extLst xmlns:a="http://schemas.openxmlformats.org/drawingml/2006/main">
               <a:ext uri="{FF2B5EF4-FFF2-40B4-BE49-F238E27FC236}">
-                <a16:creationId xmlns:a16="http://schemas.microsoft.com/office/drawing/2014/main" id="{8A19C0F2-4C67-4D2A-BD9B-31D83995894B}"/>
+                <a16:creationId xmlns:a16="http://schemas.microsoft.com/office/drawing/2014/main" id="{6CB84EF4-4278-44A8-B412-79F5BF8479BF}"/>
               </a:ext>
             </a:extLst>
           </p:cNvPr>
@@ -8174,7 +8174,7 @@
           <p:cNvPr id="6" name="">
             <a:extLst xmlns:a="http://schemas.openxmlformats.org/drawingml/2006/main">
               <a:ext uri="{FF2B5EF4-FFF2-40B4-BE49-F238E27FC236}">
-                <a16:creationId xmlns:a16="http://schemas.microsoft.com/office/drawing/2014/main" id="{8235E104-566E-4D6C-95EB-048470802C8C}"/>
+                <a16:creationId xmlns:a16="http://schemas.microsoft.com/office/drawing/2014/main" id="{625BA4FD-CE95-42F3-9CDE-FC68C9697FC4}"/>
               </a:ext>
             </a:extLst>
           </p:cNvPr>
@@ -8236,7 +8236,7 @@
           <p:cNvPr id="7" name="">
             <a:extLst xmlns:a="http://schemas.openxmlformats.org/drawingml/2006/main">
               <a:ext uri="{FF2B5EF4-FFF2-40B4-BE49-F238E27FC236}">
-                <a16:creationId xmlns:a16="http://schemas.microsoft.com/office/drawing/2014/main" id="{CE7534BA-D5C5-446B-94E2-93C1F56D8D08}"/>
+                <a16:creationId xmlns:a16="http://schemas.microsoft.com/office/drawing/2014/main" id="{96B9BE4F-6601-4FDC-9CDA-04DFBE3F3925}"/>
               </a:ext>
             </a:extLst>
           </p:cNvPr>
@@ -8278,7 +8278,7 @@
           <p:cNvPr id="8" name="">
             <a:extLst xmlns:a="http://schemas.openxmlformats.org/drawingml/2006/main">
               <a:ext uri="{FF2B5EF4-FFF2-40B4-BE49-F238E27FC236}">
-                <a16:creationId xmlns:a16="http://schemas.microsoft.com/office/drawing/2014/main" id="{2C07B301-2251-4605-ABE1-4C6BFA18D0FB}"/>
+                <a16:creationId xmlns:a16="http://schemas.microsoft.com/office/drawing/2014/main" id="{4EC12340-1269-42F2-B4F7-6F36A21DD9DA}"/>
               </a:ext>
             </a:extLst>
           </p:cNvPr>
@@ -8340,7 +8340,7 @@
           <p:cNvPr id="9" name="">
             <a:extLst xmlns:a="http://schemas.openxmlformats.org/drawingml/2006/main">
               <a:ext uri="{FF2B5EF4-FFF2-40B4-BE49-F238E27FC236}">
-                <a16:creationId xmlns:a16="http://schemas.microsoft.com/office/drawing/2014/main" id="{F91DBA7D-0DE9-40CA-AFF1-379F00DE127B}"/>
+                <a16:creationId xmlns:a16="http://schemas.microsoft.com/office/drawing/2014/main" id="{59AE2F37-9E75-49DC-95CC-7368AB8B569E}"/>
               </a:ext>
             </a:extLst>
           </p:cNvPr>
@@ -8402,7 +8402,7 @@
           <p:cNvPr id="10" name="">
             <a:extLst xmlns:a="http://schemas.openxmlformats.org/drawingml/2006/main">
               <a:ext uri="{FF2B5EF4-FFF2-40B4-BE49-F238E27FC236}">
-                <a16:creationId xmlns:a16="http://schemas.microsoft.com/office/drawing/2014/main" id="{3AAC4819-EEAD-411C-8B5E-E51D98CF6EE7}"/>
+                <a16:creationId xmlns:a16="http://schemas.microsoft.com/office/drawing/2014/main" id="{5F2324B6-6E89-4E19-956C-DB5AE257708D}"/>
               </a:ext>
             </a:extLst>
           </p:cNvPr>
@@ -8444,7 +8444,7 @@
           <p:cNvPr id="11" name="">
             <a:extLst xmlns:a="http://schemas.openxmlformats.org/drawingml/2006/main">
               <a:ext uri="{FF2B5EF4-FFF2-40B4-BE49-F238E27FC236}">
-                <a16:creationId xmlns:a16="http://schemas.microsoft.com/office/drawing/2014/main" id="{32BC528F-954D-4844-814B-1672C0570C74}"/>
+                <a16:creationId xmlns:a16="http://schemas.microsoft.com/office/drawing/2014/main" id="{D9D86E39-EA0B-4114-AEE9-E114B1E0E81C}"/>
               </a:ext>
             </a:extLst>
           </p:cNvPr>
@@ -8506,7 +8506,7 @@
           <p:cNvPr id="12" name="">
             <a:extLst xmlns:a="http://schemas.openxmlformats.org/drawingml/2006/main">
               <a:ext uri="{FF2B5EF4-FFF2-40B4-BE49-F238E27FC236}">
-                <a16:creationId xmlns:a16="http://schemas.microsoft.com/office/drawing/2014/main" id="{E9481CF7-666F-47F2-BD22-3A4027B5D422}"/>
+                <a16:creationId xmlns:a16="http://schemas.microsoft.com/office/drawing/2014/main" id="{C68032D3-407B-4D8E-93B4-16D6A5F97591}"/>
               </a:ext>
             </a:extLst>
           </p:cNvPr>
@@ -8568,7 +8568,7 @@
           <p:cNvPr id="13" name="">
             <a:extLst xmlns:a="http://schemas.openxmlformats.org/drawingml/2006/main">
               <a:ext uri="{FF2B5EF4-FFF2-40B4-BE49-F238E27FC236}">
-                <a16:creationId xmlns:a16="http://schemas.microsoft.com/office/drawing/2014/main" id="{A73D9AB0-4689-407C-A60A-614DA066B162}"/>
+                <a16:creationId xmlns:a16="http://schemas.microsoft.com/office/drawing/2014/main" id="{B3E55CDF-C154-4DB3-827E-EC09086F9047}"/>
               </a:ext>
             </a:extLst>
           </p:cNvPr>
@@ -8610,7 +8610,7 @@
           <p:cNvPr id="14" name="">
             <a:extLst xmlns:a="http://schemas.openxmlformats.org/drawingml/2006/main">
               <a:ext uri="{FF2B5EF4-FFF2-40B4-BE49-F238E27FC236}">
-                <a16:creationId xmlns:a16="http://schemas.microsoft.com/office/drawing/2014/main" id="{7028DC4D-7B1B-4D1C-A18E-FC3F1E21A1DA}"/>
+                <a16:creationId xmlns:a16="http://schemas.microsoft.com/office/drawing/2014/main" id="{E6EBC9B8-2839-490F-8CB1-B6F4322038CB}"/>
               </a:ext>
             </a:extLst>
           </p:cNvPr>
@@ -8672,7 +8672,7 @@
           <p:cNvPr id="15" name="">
             <a:extLst xmlns:a="http://schemas.openxmlformats.org/drawingml/2006/main">
               <a:ext uri="{FF2B5EF4-FFF2-40B4-BE49-F238E27FC236}">
-                <a16:creationId xmlns:a16="http://schemas.microsoft.com/office/drawing/2014/main" id="{B14B8577-C271-4B37-A7B8-02B86A395A84}"/>
+                <a16:creationId xmlns:a16="http://schemas.microsoft.com/office/drawing/2014/main" id="{5F76BB64-6970-44B5-8F8C-0CA1EF58B98B}"/>
               </a:ext>
             </a:extLst>
           </p:cNvPr>
@@ -8732,7 +8732,7 @@
     </p:spTree>
     <p:extLst>
       <p:ext uri="{BB962C8B-B14F-4D97-AF65-F5344CB8AC3E}">
-        <p14:creationId xmlns:p14="http://schemas.microsoft.com/office/powerpoint/2010/main" val="781237187"/>
+        <p14:creationId xmlns:p14="http://schemas.microsoft.com/office/powerpoint/2010/main" val="1367599169"/>
       </p:ext>
     </p:extLst>
   </p:cSld>
@@ -8756,7 +8756,7 @@
           <p:cNvPr id="25" name="">
             <a:extLst xmlns:a="http://schemas.openxmlformats.org/drawingml/2006/main">
               <a:ext uri="{FF2B5EF4-FFF2-40B4-BE49-F238E27FC236}">
-                <a16:creationId xmlns:a16="http://schemas.microsoft.com/office/drawing/2014/main" id="{FDE879F3-F637-4F7E-BA08-4B372A20A057}"/>
+                <a16:creationId xmlns:a16="http://schemas.microsoft.com/office/drawing/2014/main" id="{B4C822CE-575D-43AC-A5A2-9E8FF635E6E2}"/>
               </a:ext>
             </a:extLst>
           </p:cNvPr>
@@ -8818,7 +8818,7 @@
           <p:cNvPr id="2" name="">
             <a:extLst xmlns:a="http://schemas.openxmlformats.org/drawingml/2006/main">
               <a:ext uri="{FF2B5EF4-FFF2-40B4-BE49-F238E27FC236}">
-                <a16:creationId xmlns:a16="http://schemas.microsoft.com/office/drawing/2014/main" id="{DFF58765-434D-4FB2-9388-DD96BA2094BC}"/>
+                <a16:creationId xmlns:a16="http://schemas.microsoft.com/office/drawing/2014/main" id="{6E1C816C-886A-4508-8B39-8443DF1D3C43}"/>
               </a:ext>
             </a:extLst>
           </p:cNvPr>
@@ -8880,7 +8880,7 @@
           <p:cNvPr id="3" name="">
             <a:extLst xmlns:a="http://schemas.openxmlformats.org/drawingml/2006/main">
               <a:ext uri="{FF2B5EF4-FFF2-40B4-BE49-F238E27FC236}">
-                <a16:creationId xmlns:a16="http://schemas.microsoft.com/office/drawing/2014/main" id="{7BE6F5C5-20D5-4C16-864F-B75F3C352E68}"/>
+                <a16:creationId xmlns:a16="http://schemas.microsoft.com/office/drawing/2014/main" id="{FC8C83C8-225B-4736-8F2A-9397FEF13272}"/>
               </a:ext>
             </a:extLst>
           </p:cNvPr>
@@ -8942,7 +8942,7 @@
           <p:cNvPr id="4" name="">
             <a:extLst xmlns:a="http://schemas.openxmlformats.org/drawingml/2006/main">
               <a:ext uri="{FF2B5EF4-FFF2-40B4-BE49-F238E27FC236}">
-                <a16:creationId xmlns:a16="http://schemas.microsoft.com/office/drawing/2014/main" id="{3CAE6AFA-F895-4742-A2D6-1D0AC29AD5F0}"/>
+                <a16:creationId xmlns:a16="http://schemas.microsoft.com/office/drawing/2014/main" id="{A9EA92F0-34B5-4FDE-87D9-F2F88325A130}"/>
               </a:ext>
             </a:extLst>
           </p:cNvPr>
@@ -8977,7 +8977,7 @@
           <p:cNvPr id="5" name="">
             <a:extLst xmlns:a="http://schemas.openxmlformats.org/drawingml/2006/main">
               <a:ext uri="{FF2B5EF4-FFF2-40B4-BE49-F238E27FC236}">
-                <a16:creationId xmlns:a16="http://schemas.microsoft.com/office/drawing/2014/main" id="{EDA9EAF4-CAF9-4288-96A1-4B412CC2A117}"/>
+                <a16:creationId xmlns:a16="http://schemas.microsoft.com/office/drawing/2014/main" id="{3BDA2CCC-C6B3-4064-B86F-1BC3B5A82A83}"/>
               </a:ext>
             </a:extLst>
           </p:cNvPr>
@@ -9008,7 +9008,7 @@
           <p:cNvPr id="6" name="">
             <a:extLst xmlns:a="http://schemas.openxmlformats.org/drawingml/2006/main">
               <a:ext uri="{FF2B5EF4-FFF2-40B4-BE49-F238E27FC236}">
-                <a16:creationId xmlns:a16="http://schemas.microsoft.com/office/drawing/2014/main" id="{44EB7B1E-7E88-48C6-BC29-89835601AA8C}"/>
+                <a16:creationId xmlns:a16="http://schemas.microsoft.com/office/drawing/2014/main" id="{89C4F607-BC77-4FA7-A7F6-A3C4C03A481C}"/>
               </a:ext>
             </a:extLst>
           </p:cNvPr>
@@ -9070,7 +9070,7 @@
           <p:cNvPr id="7" name="">
             <a:extLst xmlns:a="http://schemas.openxmlformats.org/drawingml/2006/main">
               <a:ext uri="{FF2B5EF4-FFF2-40B4-BE49-F238E27FC236}">
-                <a16:creationId xmlns:a16="http://schemas.microsoft.com/office/drawing/2014/main" id="{EF2D1B00-DC01-410F-8EBA-49D2E0B3B614}"/>
+                <a16:creationId xmlns:a16="http://schemas.microsoft.com/office/drawing/2014/main" id="{0D799CD9-65E8-49A5-AD60-941304EDBBFA}"/>
               </a:ext>
             </a:extLst>
           </p:cNvPr>
@@ -9132,7 +9132,7 @@
           <p:cNvPr id="8" name="">
             <a:extLst xmlns:a="http://schemas.openxmlformats.org/drawingml/2006/main">
               <a:ext uri="{FF2B5EF4-FFF2-40B4-BE49-F238E27FC236}">
-                <a16:creationId xmlns:a16="http://schemas.microsoft.com/office/drawing/2014/main" id="{09C28EEF-4E04-41F3-9087-239C365EE98E}"/>
+                <a16:creationId xmlns:a16="http://schemas.microsoft.com/office/drawing/2014/main" id="{73F0845E-0F36-43A8-A987-9E0D2082E1B6}"/>
               </a:ext>
             </a:extLst>
           </p:cNvPr>
@@ -9194,7 +9194,7 @@
           <p:cNvPr id="9" name="">
             <a:extLst xmlns:a="http://schemas.openxmlformats.org/drawingml/2006/main">
               <a:ext uri="{FF2B5EF4-FFF2-40B4-BE49-F238E27FC236}">
-                <a16:creationId xmlns:a16="http://schemas.microsoft.com/office/drawing/2014/main" id="{016E0220-A9B8-4F89-9386-8173963689B3}"/>
+                <a16:creationId xmlns:a16="http://schemas.microsoft.com/office/drawing/2014/main" id="{C08D7E79-C490-4E92-8EDB-DFA59F1A279B}"/>
               </a:ext>
             </a:extLst>
           </p:cNvPr>
@@ -9229,7 +9229,7 @@
           <p:cNvPr id="10" name="">
             <a:extLst xmlns:a="http://schemas.openxmlformats.org/drawingml/2006/main">
               <a:ext uri="{FF2B5EF4-FFF2-40B4-BE49-F238E27FC236}">
-                <a16:creationId xmlns:a16="http://schemas.microsoft.com/office/drawing/2014/main" id="{DA39F3C1-4322-40BD-BB4A-78A69562BA78}"/>
+                <a16:creationId xmlns:a16="http://schemas.microsoft.com/office/drawing/2014/main" id="{823103B2-DA1A-43EA-9247-A94DB0A6E93A}"/>
               </a:ext>
             </a:extLst>
           </p:cNvPr>
@@ -9260,7 +9260,7 @@
           <p:cNvPr id="11" name="">
             <a:extLst xmlns:a="http://schemas.openxmlformats.org/drawingml/2006/main">
               <a:ext uri="{FF2B5EF4-FFF2-40B4-BE49-F238E27FC236}">
-                <a16:creationId xmlns:a16="http://schemas.microsoft.com/office/drawing/2014/main" id="{3F734013-4D3C-4903-A36B-A133F3A8A1AE}"/>
+                <a16:creationId xmlns:a16="http://schemas.microsoft.com/office/drawing/2014/main" id="{2538C0B5-8A28-4E6D-9055-2174F7971907}"/>
               </a:ext>
             </a:extLst>
           </p:cNvPr>
@@ -9322,7 +9322,7 @@
           <p:cNvPr id="12" name="">
             <a:extLst xmlns:a="http://schemas.openxmlformats.org/drawingml/2006/main">
               <a:ext uri="{FF2B5EF4-FFF2-40B4-BE49-F238E27FC236}">
-                <a16:creationId xmlns:a16="http://schemas.microsoft.com/office/drawing/2014/main" id="{C5D15CE0-37AD-4C17-90F9-A7E4FEFF796E}"/>
+                <a16:creationId xmlns:a16="http://schemas.microsoft.com/office/drawing/2014/main" id="{D6F6D227-DEDC-4897-90E0-97D7C0834963}"/>
               </a:ext>
             </a:extLst>
           </p:cNvPr>
@@ -9384,7 +9384,7 @@
           <p:cNvPr id="13" name="">
             <a:extLst xmlns:a="http://schemas.openxmlformats.org/drawingml/2006/main">
               <a:ext uri="{FF2B5EF4-FFF2-40B4-BE49-F238E27FC236}">
-                <a16:creationId xmlns:a16="http://schemas.microsoft.com/office/drawing/2014/main" id="{AEB53D89-EC45-4E33-B14E-B5AFFB73D1B4}"/>
+                <a16:creationId xmlns:a16="http://schemas.microsoft.com/office/drawing/2014/main" id="{DF2065A3-B1A1-489E-87C0-26D398E00731}"/>
               </a:ext>
             </a:extLst>
           </p:cNvPr>
@@ -9446,7 +9446,7 @@
           <p:cNvPr id="14" name="">
             <a:extLst xmlns:a="http://schemas.openxmlformats.org/drawingml/2006/main">
               <a:ext uri="{FF2B5EF4-FFF2-40B4-BE49-F238E27FC236}">
-                <a16:creationId xmlns:a16="http://schemas.microsoft.com/office/drawing/2014/main" id="{6ADE1088-899E-4D80-BA55-5BD937D69EF4}"/>
+                <a16:creationId xmlns:a16="http://schemas.microsoft.com/office/drawing/2014/main" id="{632AE10A-BAF0-4E13-9825-745B302F4F63}"/>
               </a:ext>
             </a:extLst>
           </p:cNvPr>
@@ -9481,7 +9481,7 @@
           <p:cNvPr id="15" name="">
             <a:extLst xmlns:a="http://schemas.openxmlformats.org/drawingml/2006/main">
               <a:ext uri="{FF2B5EF4-FFF2-40B4-BE49-F238E27FC236}">
-                <a16:creationId xmlns:a16="http://schemas.microsoft.com/office/drawing/2014/main" id="{C9E3AF3F-A4A8-4E75-865D-104992C717E8}"/>
+                <a16:creationId xmlns:a16="http://schemas.microsoft.com/office/drawing/2014/main" id="{B8EFCCC1-EAE8-484F-8EC9-B904659374D1}"/>
               </a:ext>
             </a:extLst>
           </p:cNvPr>
@@ -9512,7 +9512,7 @@
           <p:cNvPr id="16" name="">
             <a:extLst xmlns:a="http://schemas.openxmlformats.org/drawingml/2006/main">
               <a:ext uri="{FF2B5EF4-FFF2-40B4-BE49-F238E27FC236}">
-                <a16:creationId xmlns:a16="http://schemas.microsoft.com/office/drawing/2014/main" id="{1CC1F506-8F87-42EB-A16C-4F68C9D87440}"/>
+                <a16:creationId xmlns:a16="http://schemas.microsoft.com/office/drawing/2014/main" id="{89054443-DF74-4EC0-85ED-DAE0152AF26D}"/>
               </a:ext>
             </a:extLst>
           </p:cNvPr>
@@ -9574,7 +9574,7 @@
           <p:cNvPr id="17" name="">
             <a:extLst xmlns:a="http://schemas.openxmlformats.org/drawingml/2006/main">
               <a:ext uri="{FF2B5EF4-FFF2-40B4-BE49-F238E27FC236}">
-                <a16:creationId xmlns:a16="http://schemas.microsoft.com/office/drawing/2014/main" id="{06599181-F10A-47D4-B0B8-13A61F26A35B}"/>
+                <a16:creationId xmlns:a16="http://schemas.microsoft.com/office/drawing/2014/main" id="{6E13892A-8B2B-4587-AA37-EE5F011B0BD1}"/>
               </a:ext>
             </a:extLst>
           </p:cNvPr>
@@ -9636,7 +9636,7 @@
           <p:cNvPr id="18" name="">
             <a:extLst xmlns:a="http://schemas.openxmlformats.org/drawingml/2006/main">
               <a:ext uri="{FF2B5EF4-FFF2-40B4-BE49-F238E27FC236}">
-                <a16:creationId xmlns:a16="http://schemas.microsoft.com/office/drawing/2014/main" id="{5F664D2F-0CA0-473F-995A-1C3EB83B7F2F}"/>
+                <a16:creationId xmlns:a16="http://schemas.microsoft.com/office/drawing/2014/main" id="{37AC466C-0406-4720-AE30-7D46EFB01677}"/>
               </a:ext>
             </a:extLst>
           </p:cNvPr>
@@ -9698,7 +9698,7 @@
           <p:cNvPr id="19" name="">
             <a:extLst xmlns:a="http://schemas.openxmlformats.org/drawingml/2006/main">
               <a:ext uri="{FF2B5EF4-FFF2-40B4-BE49-F238E27FC236}">
-                <a16:creationId xmlns:a16="http://schemas.microsoft.com/office/drawing/2014/main" id="{47386BE7-D01C-453C-B1E1-9EA1E1D48EFF}"/>
+                <a16:creationId xmlns:a16="http://schemas.microsoft.com/office/drawing/2014/main" id="{BE3FBD4B-83A2-44DB-B729-ED14E16F7DEB}"/>
               </a:ext>
             </a:extLst>
           </p:cNvPr>
@@ -9733,7 +9733,7 @@
           <p:cNvPr id="20" name="">
             <a:extLst xmlns:a="http://schemas.openxmlformats.org/drawingml/2006/main">
               <a:ext uri="{FF2B5EF4-FFF2-40B4-BE49-F238E27FC236}">
-                <a16:creationId xmlns:a16="http://schemas.microsoft.com/office/drawing/2014/main" id="{229B929A-FD02-4F8B-9B46-5B54EE123FD3}"/>
+                <a16:creationId xmlns:a16="http://schemas.microsoft.com/office/drawing/2014/main" id="{F5854876-3DD0-48F5-83F1-CA173C251B28}"/>
               </a:ext>
             </a:extLst>
           </p:cNvPr>
@@ -9764,7 +9764,7 @@
           <p:cNvPr id="21" name="">
             <a:extLst xmlns:a="http://schemas.openxmlformats.org/drawingml/2006/main">
               <a:ext uri="{FF2B5EF4-FFF2-40B4-BE49-F238E27FC236}">
-                <a16:creationId xmlns:a16="http://schemas.microsoft.com/office/drawing/2014/main" id="{32B0DE39-2DCC-4D12-9DE2-BDD8FB3A9A35}"/>
+                <a16:creationId xmlns:a16="http://schemas.microsoft.com/office/drawing/2014/main" id="{29EA351E-4479-4871-9488-D5D9512D899A}"/>
               </a:ext>
             </a:extLst>
           </p:cNvPr>
@@ -9826,7 +9826,7 @@
           <p:cNvPr id="22" name="">
             <a:extLst xmlns:a="http://schemas.openxmlformats.org/drawingml/2006/main">
               <a:ext uri="{FF2B5EF4-FFF2-40B4-BE49-F238E27FC236}">
-                <a16:creationId xmlns:a16="http://schemas.microsoft.com/office/drawing/2014/main" id="{A949620F-6B0C-4C28-9B51-2D89A485DB2A}"/>
+                <a16:creationId xmlns:a16="http://schemas.microsoft.com/office/drawing/2014/main" id="{4301F709-7CF3-4C2B-AB8E-7F962133037A}"/>
               </a:ext>
             </a:extLst>
           </p:cNvPr>
@@ -9888,7 +9888,7 @@
           <p:cNvPr id="23" name="">
             <a:extLst xmlns:a="http://schemas.openxmlformats.org/drawingml/2006/main">
               <a:ext uri="{FF2B5EF4-FFF2-40B4-BE49-F238E27FC236}">
-                <a16:creationId xmlns:a16="http://schemas.microsoft.com/office/drawing/2014/main" id="{C60D5F57-842A-4E4D-B8BB-2A334C59C0A9}"/>
+                <a16:creationId xmlns:a16="http://schemas.microsoft.com/office/drawing/2014/main" id="{FE005678-7087-47D6-B957-F0F6A2A6CE59}"/>
               </a:ext>
             </a:extLst>
           </p:cNvPr>
@@ -9950,7 +9950,7 @@
           <p:cNvPr id="24" name="">
             <a:extLst xmlns:a="http://schemas.openxmlformats.org/drawingml/2006/main">
               <a:ext uri="{FF2B5EF4-FFF2-40B4-BE49-F238E27FC236}">
-                <a16:creationId xmlns:a16="http://schemas.microsoft.com/office/drawing/2014/main" id="{56D4B76D-9225-42B5-BBE3-6669F0972FE8}"/>
+                <a16:creationId xmlns:a16="http://schemas.microsoft.com/office/drawing/2014/main" id="{C2B29AF7-B8E4-4257-A0AD-7ED4968F3833}"/>
               </a:ext>
             </a:extLst>
           </p:cNvPr>
@@ -10010,7 +10010,7 @@
     </p:spTree>
     <p:extLst>
       <p:ext uri="{BB962C8B-B14F-4D97-AF65-F5344CB8AC3E}">
-        <p14:creationId xmlns:p14="http://schemas.microsoft.com/office/powerpoint/2010/main" val="637244344"/>
+        <p14:creationId xmlns:p14="http://schemas.microsoft.com/office/powerpoint/2010/main" val="524799257"/>
       </p:ext>
     </p:extLst>
   </p:cSld>
@@ -10034,7 +10034,7 @@
           <p:cNvPr id="6" name="">
             <a:extLst xmlns:a="http://schemas.openxmlformats.org/drawingml/2006/main">
               <a:ext uri="{FF2B5EF4-FFF2-40B4-BE49-F238E27FC236}">
-                <a16:creationId xmlns:a16="http://schemas.microsoft.com/office/drawing/2014/main" id="{698F0825-F9FD-4DF1-91B6-D57C216F70FC}"/>
+                <a16:creationId xmlns:a16="http://schemas.microsoft.com/office/drawing/2014/main" id="{F66F8E66-F972-4A6A-B267-C33A7B81DA52}"/>
               </a:ext>
             </a:extLst>
           </p:cNvPr>
@@ -10096,7 +10096,7 @@
           <p:cNvPr id="2" name="">
             <a:extLst xmlns:a="http://schemas.openxmlformats.org/drawingml/2006/main">
               <a:ext uri="{FF2B5EF4-FFF2-40B4-BE49-F238E27FC236}">
-                <a16:creationId xmlns:a16="http://schemas.microsoft.com/office/drawing/2014/main" id="{7A627141-D36A-4795-A47D-EA9594911B0D}"/>
+                <a16:creationId xmlns:a16="http://schemas.microsoft.com/office/drawing/2014/main" id="{33DAEF64-2D07-4403-868C-9415DDDF9112}"/>
               </a:ext>
             </a:extLst>
           </p:cNvPr>
@@ -10158,7 +10158,7 @@
           <p:cNvPr id="3" name="">
             <a:extLst xmlns:a="http://schemas.openxmlformats.org/drawingml/2006/main">
               <a:ext uri="{FF2B5EF4-FFF2-40B4-BE49-F238E27FC236}">
-                <a16:creationId xmlns:a16="http://schemas.microsoft.com/office/drawing/2014/main" id="{BD8F7702-3A33-4293-87BB-F7AB82A9AE21}"/>
+                <a16:creationId xmlns:a16="http://schemas.microsoft.com/office/drawing/2014/main" id="{BEC85E7C-A995-4F20-98E3-10A4745F4A47}"/>
               </a:ext>
             </a:extLst>
           </p:cNvPr>
@@ -10220,7 +10220,7 @@
           <p:cNvPr id="4" name="">
             <a:extLst xmlns:a="http://schemas.openxmlformats.org/drawingml/2006/main">
               <a:ext uri="{FF2B5EF4-FFF2-40B4-BE49-F238E27FC236}">
-                <a16:creationId xmlns:a16="http://schemas.microsoft.com/office/drawing/2014/main" id="{D68E93A2-1AE7-4AC6-97E9-3C7D16664154}"/>
+                <a16:creationId xmlns:a16="http://schemas.microsoft.com/office/drawing/2014/main" id="{ED97A2C9-D161-41E8-86CB-482E180808CF}"/>
               </a:ext>
             </a:extLst>
           </p:cNvPr>
@@ -10639,7 +10639,7 @@
           <p:cNvPr id="5" name="">
             <a:extLst xmlns:a="http://schemas.openxmlformats.org/drawingml/2006/main">
               <a:ext uri="{FF2B5EF4-FFF2-40B4-BE49-F238E27FC236}">
-                <a16:creationId xmlns:a16="http://schemas.microsoft.com/office/drawing/2014/main" id="{F35C3AF9-7FDE-4FEB-9936-4897D14D465C}"/>
+                <a16:creationId xmlns:a16="http://schemas.microsoft.com/office/drawing/2014/main" id="{AF68BC33-2B07-4E7C-A4A2-60793F5FF37F}"/>
               </a:ext>
             </a:extLst>
           </p:cNvPr>
@@ -10699,7 +10699,7 @@
     </p:spTree>
     <p:extLst>
       <p:ext uri="{BB962C8B-B14F-4D97-AF65-F5344CB8AC3E}">
-        <p14:creationId xmlns:p14="http://schemas.microsoft.com/office/powerpoint/2010/main" val="740414542"/>
+        <p14:creationId xmlns:p14="http://schemas.microsoft.com/office/powerpoint/2010/main" val="534673313"/>
       </p:ext>
     </p:extLst>
   </p:cSld>
@@ -10723,7 +10723,7 @@
           <p:cNvPr id="16" name="">
             <a:extLst xmlns:a="http://schemas.openxmlformats.org/drawingml/2006/main">
               <a:ext uri="{FF2B5EF4-FFF2-40B4-BE49-F238E27FC236}">
-                <a16:creationId xmlns:a16="http://schemas.microsoft.com/office/drawing/2014/main" id="{A5E9207C-A4BB-4620-94DA-DEE40DFD6796}"/>
+                <a16:creationId xmlns:a16="http://schemas.microsoft.com/office/drawing/2014/main" id="{B1A0E122-BAD7-42FF-8339-B294173F962E}"/>
               </a:ext>
             </a:extLst>
           </p:cNvPr>
@@ -10785,7 +10785,7 @@
           <p:cNvPr id="2" name="">
             <a:extLst xmlns:a="http://schemas.openxmlformats.org/drawingml/2006/main">
               <a:ext uri="{FF2B5EF4-FFF2-40B4-BE49-F238E27FC236}">
-                <a16:creationId xmlns:a16="http://schemas.microsoft.com/office/drawing/2014/main" id="{DCBFE83D-885C-4E5F-BBE8-8C3DB386DB1C}"/>
+                <a16:creationId xmlns:a16="http://schemas.microsoft.com/office/drawing/2014/main" id="{DA62C50B-2566-4315-9937-3DAD8B908D70}"/>
               </a:ext>
             </a:extLst>
           </p:cNvPr>
@@ -10847,7 +10847,7 @@
           <p:cNvPr id="3" name="">
             <a:extLst xmlns:a="http://schemas.openxmlformats.org/drawingml/2006/main">
               <a:ext uri="{FF2B5EF4-FFF2-40B4-BE49-F238E27FC236}">
-                <a16:creationId xmlns:a16="http://schemas.microsoft.com/office/drawing/2014/main" id="{75A84E44-341B-4C47-BE7C-FEBA1CE6D1F2}"/>
+                <a16:creationId xmlns:a16="http://schemas.microsoft.com/office/drawing/2014/main" id="{A6AB3A17-3BB3-4E88-B2BC-76DBF16A34D5}"/>
               </a:ext>
             </a:extLst>
           </p:cNvPr>
@@ -10909,7 +10909,7 @@
           <p:cNvPr id="4" name="">
             <a:extLst xmlns:a="http://schemas.openxmlformats.org/drawingml/2006/main">
               <a:ext uri="{FF2B5EF4-FFF2-40B4-BE49-F238E27FC236}">
-                <a16:creationId xmlns:a16="http://schemas.microsoft.com/office/drawing/2014/main" id="{680278D5-C71E-48F2-9120-8EB6583F45E3}"/>
+                <a16:creationId xmlns:a16="http://schemas.microsoft.com/office/drawing/2014/main" id="{10C77268-B543-4900-A813-4F58CFD3F8C0}"/>
               </a:ext>
             </a:extLst>
           </p:cNvPr>
@@ -10944,7 +10944,7 @@
           <p:cNvPr id="5" name="">
             <a:extLst xmlns:a="http://schemas.openxmlformats.org/drawingml/2006/main">
               <a:ext uri="{FF2B5EF4-FFF2-40B4-BE49-F238E27FC236}">
-                <a16:creationId xmlns:a16="http://schemas.microsoft.com/office/drawing/2014/main" id="{E7644068-0B9F-41B8-9623-B14384B92F36}"/>
+                <a16:creationId xmlns:a16="http://schemas.microsoft.com/office/drawing/2014/main" id="{D2C381E8-6B97-453C-8788-B48F48E1AA29}"/>
               </a:ext>
             </a:extLst>
           </p:cNvPr>
@@ -11006,7 +11006,7 @@
           <p:cNvPr id="6" name="">
             <a:extLst xmlns:a="http://schemas.openxmlformats.org/drawingml/2006/main">
               <a:ext uri="{FF2B5EF4-FFF2-40B4-BE49-F238E27FC236}">
-                <a16:creationId xmlns:a16="http://schemas.microsoft.com/office/drawing/2014/main" id="{9C6B6CF9-A1DF-4C98-A409-C15F5FB4144B}"/>
+                <a16:creationId xmlns:a16="http://schemas.microsoft.com/office/drawing/2014/main" id="{6A7B7A96-9EF8-4BB8-A822-7EA1B37B94CA}"/>
               </a:ext>
             </a:extLst>
           </p:cNvPr>
@@ -11068,7 +11068,7 @@
           <p:cNvPr id="7" name="">
             <a:extLst xmlns:a="http://schemas.openxmlformats.org/drawingml/2006/main">
               <a:ext uri="{FF2B5EF4-FFF2-40B4-BE49-F238E27FC236}">
-                <a16:creationId xmlns:a16="http://schemas.microsoft.com/office/drawing/2014/main" id="{BB85F82F-359B-47A9-97E8-7B64A1C85876}"/>
+                <a16:creationId xmlns:a16="http://schemas.microsoft.com/office/drawing/2014/main" id="{848635D8-3710-4FA0-948D-19A28FDF8751}"/>
               </a:ext>
             </a:extLst>
           </p:cNvPr>
@@ -11130,7 +11130,7 @@
           <p:cNvPr id="8" name="">
             <a:extLst xmlns:a="http://schemas.openxmlformats.org/drawingml/2006/main">
               <a:ext uri="{FF2B5EF4-FFF2-40B4-BE49-F238E27FC236}">
-                <a16:creationId xmlns:a16="http://schemas.microsoft.com/office/drawing/2014/main" id="{D1141181-167E-48F2-9961-B4FBAE110AFE}"/>
+                <a16:creationId xmlns:a16="http://schemas.microsoft.com/office/drawing/2014/main" id="{854C1EA8-164D-44D4-93B6-65D9B5E4383A}"/>
               </a:ext>
             </a:extLst>
           </p:cNvPr>
@@ -11192,7 +11192,7 @@
           <p:cNvPr id="9" name="">
             <a:extLst xmlns:a="http://schemas.openxmlformats.org/drawingml/2006/main">
               <a:ext uri="{FF2B5EF4-FFF2-40B4-BE49-F238E27FC236}">
-                <a16:creationId xmlns:a16="http://schemas.microsoft.com/office/drawing/2014/main" id="{7189321F-BB0A-449E-943E-7B5C0F49ABE3}"/>
+                <a16:creationId xmlns:a16="http://schemas.microsoft.com/office/drawing/2014/main" id="{69343119-0DE9-4142-86E4-531FDB23865E}"/>
               </a:ext>
             </a:extLst>
           </p:cNvPr>
@@ -11254,7 +11254,7 @@
           <p:cNvPr id="10" name="">
             <a:extLst xmlns:a="http://schemas.openxmlformats.org/drawingml/2006/main">
               <a:ext uri="{FF2B5EF4-FFF2-40B4-BE49-F238E27FC236}">
-                <a16:creationId xmlns:a16="http://schemas.microsoft.com/office/drawing/2014/main" id="{0DB7EE4E-E507-4032-982C-1A4601CE257C}"/>
+                <a16:creationId xmlns:a16="http://schemas.microsoft.com/office/drawing/2014/main" id="{D8A4E231-2CB6-4BC0-B9AE-86B5DB4BA3F3}"/>
               </a:ext>
             </a:extLst>
           </p:cNvPr>
@@ -11289,7 +11289,7 @@
           <p:cNvPr id="11" name="">
             <a:extLst xmlns:a="http://schemas.openxmlformats.org/drawingml/2006/main">
               <a:ext uri="{FF2B5EF4-FFF2-40B4-BE49-F238E27FC236}">
-                <a16:creationId xmlns:a16="http://schemas.microsoft.com/office/drawing/2014/main" id="{27F448E2-D5D6-49B5-8F22-692101DB94DA}"/>
+                <a16:creationId xmlns:a16="http://schemas.microsoft.com/office/drawing/2014/main" id="{6755B91B-ADA9-4EA3-A298-BE596664E9C6}"/>
               </a:ext>
             </a:extLst>
           </p:cNvPr>
@@ -11351,7 +11351,7 @@
           <p:cNvPr id="12" name="">
             <a:extLst xmlns:a="http://schemas.openxmlformats.org/drawingml/2006/main">
               <a:ext uri="{FF2B5EF4-FFF2-40B4-BE49-F238E27FC236}">
-                <a16:creationId xmlns:a16="http://schemas.microsoft.com/office/drawing/2014/main" id="{374A32EC-B514-4446-A366-2B4BD3DDC9C8}"/>
+                <a16:creationId xmlns:a16="http://schemas.microsoft.com/office/drawing/2014/main" id="{F96E9353-AE15-4BF4-B199-489D206E1201}"/>
               </a:ext>
             </a:extLst>
           </p:cNvPr>
@@ -11413,7 +11413,7 @@
           <p:cNvPr id="13" name="">
             <a:extLst xmlns:a="http://schemas.openxmlformats.org/drawingml/2006/main">
               <a:ext uri="{FF2B5EF4-FFF2-40B4-BE49-F238E27FC236}">
-                <a16:creationId xmlns:a16="http://schemas.microsoft.com/office/drawing/2014/main" id="{C49CBA58-A11A-4BF1-B7F2-772A74CBFFE7}"/>
+                <a16:creationId xmlns:a16="http://schemas.microsoft.com/office/drawing/2014/main" id="{4942867B-5E51-4220-B40A-1190F7A93672}"/>
               </a:ext>
             </a:extLst>
           </p:cNvPr>
@@ -11475,7 +11475,7 @@
           <p:cNvPr id="14" name="">
             <a:extLst xmlns:a="http://schemas.openxmlformats.org/drawingml/2006/main">
               <a:ext uri="{FF2B5EF4-FFF2-40B4-BE49-F238E27FC236}">
-                <a16:creationId xmlns:a16="http://schemas.microsoft.com/office/drawing/2014/main" id="{8763C1C8-E37E-428E-B097-B1EF76B12289}"/>
+                <a16:creationId xmlns:a16="http://schemas.microsoft.com/office/drawing/2014/main" id="{9C6679D1-EBB6-4BBF-825F-9ACE44A63D42}"/>
               </a:ext>
             </a:extLst>
           </p:cNvPr>
@@ -11537,7 +11537,7 @@
           <p:cNvPr id="15" name="">
             <a:extLst xmlns:a="http://schemas.openxmlformats.org/drawingml/2006/main">
               <a:ext uri="{FF2B5EF4-FFF2-40B4-BE49-F238E27FC236}">
-                <a16:creationId xmlns:a16="http://schemas.microsoft.com/office/drawing/2014/main" id="{5EFFECB5-FFED-4605-A24C-9BD24AB20C69}"/>
+                <a16:creationId xmlns:a16="http://schemas.microsoft.com/office/drawing/2014/main" id="{2DC9D740-60AD-495A-B7A9-0027A4FFBA4E}"/>
               </a:ext>
             </a:extLst>
           </p:cNvPr>
@@ -11597,7 +11597,7 @@
     </p:spTree>
     <p:extLst>
       <p:ext uri="{BB962C8B-B14F-4D97-AF65-F5344CB8AC3E}">
-        <p14:creationId xmlns:p14="http://schemas.microsoft.com/office/powerpoint/2010/main" val="944889442"/>
+        <p14:creationId xmlns:p14="http://schemas.microsoft.com/office/powerpoint/2010/main" val="471110712"/>
       </p:ext>
     </p:extLst>
   </p:cSld>
@@ -11621,7 +11621,7 @@
           <p:cNvPr id="28" name="">
             <a:extLst xmlns:a="http://schemas.openxmlformats.org/drawingml/2006/main">
               <a:ext uri="{FF2B5EF4-FFF2-40B4-BE49-F238E27FC236}">
-                <a16:creationId xmlns:a16="http://schemas.microsoft.com/office/drawing/2014/main" id="{BBECE547-D92B-4964-95C2-3F63C7671D7C}"/>
+                <a16:creationId xmlns:a16="http://schemas.microsoft.com/office/drawing/2014/main" id="{4A25F0F5-75E4-42A5-BDBB-3FE0FE4D9217}"/>
               </a:ext>
             </a:extLst>
           </p:cNvPr>
@@ -11683,7 +11683,7 @@
           <p:cNvPr id="2" name="">
             <a:extLst xmlns:a="http://schemas.openxmlformats.org/drawingml/2006/main">
               <a:ext uri="{FF2B5EF4-FFF2-40B4-BE49-F238E27FC236}">
-                <a16:creationId xmlns:a16="http://schemas.microsoft.com/office/drawing/2014/main" id="{67F804FB-6AF9-40BA-816C-FFFD1EF144B2}"/>
+                <a16:creationId xmlns:a16="http://schemas.microsoft.com/office/drawing/2014/main" id="{034E3892-EF37-43E3-B0FC-482B6450B546}"/>
               </a:ext>
             </a:extLst>
           </p:cNvPr>
@@ -11745,7 +11745,7 @@
           <p:cNvPr id="3" name="">
             <a:extLst xmlns:a="http://schemas.openxmlformats.org/drawingml/2006/main">
               <a:ext uri="{FF2B5EF4-FFF2-40B4-BE49-F238E27FC236}">
-                <a16:creationId xmlns:a16="http://schemas.microsoft.com/office/drawing/2014/main" id="{C1B7BF57-9F18-4D91-8CBF-B641D3D6B697}"/>
+                <a16:creationId xmlns:a16="http://schemas.microsoft.com/office/drawing/2014/main" id="{CB162835-D5EF-4A5A-8509-5A7EE027E4C9}"/>
               </a:ext>
             </a:extLst>
           </p:cNvPr>
@@ -11807,7 +11807,7 @@
           <p:cNvPr id="4" name="">
             <a:extLst xmlns:a="http://schemas.openxmlformats.org/drawingml/2006/main">
               <a:ext uri="{FF2B5EF4-FFF2-40B4-BE49-F238E27FC236}">
-                <a16:creationId xmlns:a16="http://schemas.microsoft.com/office/drawing/2014/main" id="{12CCF90D-C33B-47DC-A750-AF73DAFAB230}"/>
+                <a16:creationId xmlns:a16="http://schemas.microsoft.com/office/drawing/2014/main" id="{B335FA0C-F88A-4FF1-AFE6-D4D234DF2C2C}"/>
               </a:ext>
             </a:extLst>
           </p:cNvPr>
@@ -11849,7 +11849,7 @@
           <p:cNvPr id="5" name="">
             <a:extLst xmlns:a="http://schemas.openxmlformats.org/drawingml/2006/main">
               <a:ext uri="{FF2B5EF4-FFF2-40B4-BE49-F238E27FC236}">
-                <a16:creationId xmlns:a16="http://schemas.microsoft.com/office/drawing/2014/main" id="{5058AEBF-F28E-4BE2-9276-C124B5F2EE2B}"/>
+                <a16:creationId xmlns:a16="http://schemas.microsoft.com/office/drawing/2014/main" id="{868FEBA5-BFFA-4568-BF66-581A72DEB5E8}"/>
               </a:ext>
             </a:extLst>
           </p:cNvPr>
@@ -11911,7 +11911,7 @@
           <p:cNvPr id="6" name="">
             <a:extLst xmlns:a="http://schemas.openxmlformats.org/drawingml/2006/main">
               <a:ext uri="{FF2B5EF4-FFF2-40B4-BE49-F238E27FC236}">
-                <a16:creationId xmlns:a16="http://schemas.microsoft.com/office/drawing/2014/main" id="{5C1C1734-ADEF-48C3-9505-B8DFE4045D7D}"/>
+                <a16:creationId xmlns:a16="http://schemas.microsoft.com/office/drawing/2014/main" id="{825625CB-07E5-4A23-B6D4-8CEEC639AA51}"/>
               </a:ext>
             </a:extLst>
           </p:cNvPr>
@@ -11973,7 +11973,7 @@
           <p:cNvPr id="7" name="">
             <a:extLst xmlns:a="http://schemas.openxmlformats.org/drawingml/2006/main">
               <a:ext uri="{FF2B5EF4-FFF2-40B4-BE49-F238E27FC236}">
-                <a16:creationId xmlns:a16="http://schemas.microsoft.com/office/drawing/2014/main" id="{0360E02E-D31C-4440-968B-CF79BF29EF89}"/>
+                <a16:creationId xmlns:a16="http://schemas.microsoft.com/office/drawing/2014/main" id="{78F2C54A-1E2C-47C4-B50C-8B6BA2F27846}"/>
               </a:ext>
             </a:extLst>
           </p:cNvPr>
@@ -12035,7 +12035,7 @@
           <p:cNvPr id="8" name="">
             <a:extLst xmlns:a="http://schemas.openxmlformats.org/drawingml/2006/main">
               <a:ext uri="{FF2B5EF4-FFF2-40B4-BE49-F238E27FC236}">
-                <a16:creationId xmlns:a16="http://schemas.microsoft.com/office/drawing/2014/main" id="{D056654D-660B-45EB-8E66-70470AEBA331}"/>
+                <a16:creationId xmlns:a16="http://schemas.microsoft.com/office/drawing/2014/main" id="{F9F55CA3-800C-43B4-84AE-90926451D8A6}"/>
               </a:ext>
             </a:extLst>
           </p:cNvPr>
@@ -12077,7 +12077,7 @@
           <p:cNvPr id="9" name="">
             <a:extLst xmlns:a="http://schemas.openxmlformats.org/drawingml/2006/main">
               <a:ext uri="{FF2B5EF4-FFF2-40B4-BE49-F238E27FC236}">
-                <a16:creationId xmlns:a16="http://schemas.microsoft.com/office/drawing/2014/main" id="{750863EC-AA6F-4E13-933A-84A195AAE0CC}"/>
+                <a16:creationId xmlns:a16="http://schemas.microsoft.com/office/drawing/2014/main" id="{98345D11-DD7F-4B2C-B7D3-AF375B401C1A}"/>
               </a:ext>
             </a:extLst>
           </p:cNvPr>
@@ -12139,7 +12139,7 @@
           <p:cNvPr id="10" name="">
             <a:extLst xmlns:a="http://schemas.openxmlformats.org/drawingml/2006/main">
               <a:ext uri="{FF2B5EF4-FFF2-40B4-BE49-F238E27FC236}">
-                <a16:creationId xmlns:a16="http://schemas.microsoft.com/office/drawing/2014/main" id="{3057013E-0AF9-4277-B3C7-D31BEE6E6BFC}"/>
+                <a16:creationId xmlns:a16="http://schemas.microsoft.com/office/drawing/2014/main" id="{AB66A6FF-992C-4E0F-94F9-F547C3649253}"/>
               </a:ext>
             </a:extLst>
           </p:cNvPr>
@@ -12201,7 +12201,7 @@
           <p:cNvPr id="11" name="">
             <a:extLst xmlns:a="http://schemas.openxmlformats.org/drawingml/2006/main">
               <a:ext uri="{FF2B5EF4-FFF2-40B4-BE49-F238E27FC236}">
-                <a16:creationId xmlns:a16="http://schemas.microsoft.com/office/drawing/2014/main" id="{BD88DF38-61D3-4C59-AE5F-A6D50FB16ACF}"/>
+                <a16:creationId xmlns:a16="http://schemas.microsoft.com/office/drawing/2014/main" id="{8FA63C31-1ADD-478F-BB0B-B8E742C0555C}"/>
               </a:ext>
             </a:extLst>
           </p:cNvPr>
@@ -12263,7 +12263,7 @@
           <p:cNvPr id="12" name="">
             <a:extLst xmlns:a="http://schemas.openxmlformats.org/drawingml/2006/main">
               <a:ext uri="{FF2B5EF4-FFF2-40B4-BE49-F238E27FC236}">
-                <a16:creationId xmlns:a16="http://schemas.microsoft.com/office/drawing/2014/main" id="{59060587-4CE2-4A0F-94DF-AD3C63ED4236}"/>
+                <a16:creationId xmlns:a16="http://schemas.microsoft.com/office/drawing/2014/main" id="{D5CD5576-6A01-4C4D-8DA9-49AA84158F0C}"/>
               </a:ext>
             </a:extLst>
           </p:cNvPr>
@@ -12305,7 +12305,7 @@
           <p:cNvPr id="13" name="">
             <a:extLst xmlns:a="http://schemas.openxmlformats.org/drawingml/2006/main">
               <a:ext uri="{FF2B5EF4-FFF2-40B4-BE49-F238E27FC236}">
-                <a16:creationId xmlns:a16="http://schemas.microsoft.com/office/drawing/2014/main" id="{5C393CA0-66F6-43B5-8486-41AAB9F86E5A}"/>
+                <a16:creationId xmlns:a16="http://schemas.microsoft.com/office/drawing/2014/main" id="{EB96AF85-20F5-48E3-B745-520DE473F18F}"/>
               </a:ext>
             </a:extLst>
           </p:cNvPr>
@@ -12367,7 +12367,7 @@
           <p:cNvPr id="14" name="">
             <a:extLst xmlns:a="http://schemas.openxmlformats.org/drawingml/2006/main">
               <a:ext uri="{FF2B5EF4-FFF2-40B4-BE49-F238E27FC236}">
-                <a16:creationId xmlns:a16="http://schemas.microsoft.com/office/drawing/2014/main" id="{FEC95946-C539-46A7-8054-1DC67D490592}"/>
+                <a16:creationId xmlns:a16="http://schemas.microsoft.com/office/drawing/2014/main" id="{09430089-457D-4116-9397-41A4B4AA8C9B}"/>
               </a:ext>
             </a:extLst>
           </p:cNvPr>
@@ -12429,7 +12429,7 @@
           <p:cNvPr id="15" name="">
             <a:extLst xmlns:a="http://schemas.openxmlformats.org/drawingml/2006/main">
               <a:ext uri="{FF2B5EF4-FFF2-40B4-BE49-F238E27FC236}">
-                <a16:creationId xmlns:a16="http://schemas.microsoft.com/office/drawing/2014/main" id="{D566CA13-374D-4106-B3AC-13EF60F501E0}"/>
+                <a16:creationId xmlns:a16="http://schemas.microsoft.com/office/drawing/2014/main" id="{1C7DB3F4-71EE-4B65-BAAA-08E68BC57488}"/>
               </a:ext>
             </a:extLst>
           </p:cNvPr>
@@ -12491,7 +12491,7 @@
           <p:cNvPr id="16" name="">
             <a:extLst xmlns:a="http://schemas.openxmlformats.org/drawingml/2006/main">
               <a:ext uri="{FF2B5EF4-FFF2-40B4-BE49-F238E27FC236}">
-                <a16:creationId xmlns:a16="http://schemas.microsoft.com/office/drawing/2014/main" id="{ABE4F4C5-6825-42D5-B55E-732D96146F2D}"/>
+                <a16:creationId xmlns:a16="http://schemas.microsoft.com/office/drawing/2014/main" id="{7E46FEB3-786E-4C81-8F08-8DF0FB00DEDB}"/>
               </a:ext>
             </a:extLst>
           </p:cNvPr>
@@ -12533,7 +12533,7 @@
           <p:cNvPr id="17" name="">
             <a:extLst xmlns:a="http://schemas.openxmlformats.org/drawingml/2006/main">
               <a:ext uri="{FF2B5EF4-FFF2-40B4-BE49-F238E27FC236}">
-                <a16:creationId xmlns:a16="http://schemas.microsoft.com/office/drawing/2014/main" id="{2CC61E1C-D5F6-4CF2-8D99-BC6DE4448B77}"/>
+                <a16:creationId xmlns:a16="http://schemas.microsoft.com/office/drawing/2014/main" id="{B084ECAB-4AFE-43BA-9CB2-D3301E54B911}"/>
               </a:ext>
             </a:extLst>
           </p:cNvPr>
@@ -12595,7 +12595,7 @@
           <p:cNvPr id="18" name="">
             <a:extLst xmlns:a="http://schemas.openxmlformats.org/drawingml/2006/main">
               <a:ext uri="{FF2B5EF4-FFF2-40B4-BE49-F238E27FC236}">
-                <a16:creationId xmlns:a16="http://schemas.microsoft.com/office/drawing/2014/main" id="{22E5C39F-4433-41DB-9D7E-A09E1E1BCEA0}"/>
+                <a16:creationId xmlns:a16="http://schemas.microsoft.com/office/drawing/2014/main" id="{D5536AFD-3059-4EE9-AD92-1990CC0FAAB1}"/>
               </a:ext>
             </a:extLst>
           </p:cNvPr>
@@ -12657,7 +12657,7 @@
           <p:cNvPr id="19" name="">
             <a:extLst xmlns:a="http://schemas.openxmlformats.org/drawingml/2006/main">
               <a:ext uri="{FF2B5EF4-FFF2-40B4-BE49-F238E27FC236}">
-                <a16:creationId xmlns:a16="http://schemas.microsoft.com/office/drawing/2014/main" id="{0FE43389-31E9-46E1-B66B-C2E831AB94F6}"/>
+                <a16:creationId xmlns:a16="http://schemas.microsoft.com/office/drawing/2014/main" id="{454D342A-1FE3-4601-8978-0CE07B86D5AD}"/>
               </a:ext>
             </a:extLst>
           </p:cNvPr>
@@ -12719,7 +12719,7 @@
           <p:cNvPr id="20" name="">
             <a:extLst xmlns:a="http://schemas.openxmlformats.org/drawingml/2006/main">
               <a:ext uri="{FF2B5EF4-FFF2-40B4-BE49-F238E27FC236}">
-                <a16:creationId xmlns:a16="http://schemas.microsoft.com/office/drawing/2014/main" id="{536F6375-E8FC-488F-8BF9-2C8A7E3D6616}"/>
+                <a16:creationId xmlns:a16="http://schemas.microsoft.com/office/drawing/2014/main" id="{19D2C0F0-843F-497A-B858-0A0DF8902719}"/>
               </a:ext>
             </a:extLst>
           </p:cNvPr>
@@ -12761,7 +12761,7 @@
           <p:cNvPr id="21" name="">
             <a:extLst xmlns:a="http://schemas.openxmlformats.org/drawingml/2006/main">
               <a:ext uri="{FF2B5EF4-FFF2-40B4-BE49-F238E27FC236}">
-                <a16:creationId xmlns:a16="http://schemas.microsoft.com/office/drawing/2014/main" id="{3B1D4E9E-0348-4DDD-837C-EFEC45EBD789}"/>
+                <a16:creationId xmlns:a16="http://schemas.microsoft.com/office/drawing/2014/main" id="{6B180CCF-3390-4BEC-944C-5C7E0BA06E2D}"/>
               </a:ext>
             </a:extLst>
           </p:cNvPr>
@@ -12823,7 +12823,7 @@
           <p:cNvPr id="22" name="">
             <a:extLst xmlns:a="http://schemas.openxmlformats.org/drawingml/2006/main">
               <a:ext uri="{FF2B5EF4-FFF2-40B4-BE49-F238E27FC236}">
-                <a16:creationId xmlns:a16="http://schemas.microsoft.com/office/drawing/2014/main" id="{4B186AB0-7169-4DA0-96CC-EEDF508AA0E0}"/>
+                <a16:creationId xmlns:a16="http://schemas.microsoft.com/office/drawing/2014/main" id="{B7EDB687-1144-460C-AB0D-A85DC0275F2F}"/>
               </a:ext>
             </a:extLst>
           </p:cNvPr>
@@ -12885,7 +12885,7 @@
           <p:cNvPr id="23" name="">
             <a:extLst xmlns:a="http://schemas.openxmlformats.org/drawingml/2006/main">
               <a:ext uri="{FF2B5EF4-FFF2-40B4-BE49-F238E27FC236}">
-                <a16:creationId xmlns:a16="http://schemas.microsoft.com/office/drawing/2014/main" id="{6FD75CF3-5D78-4C1D-A2B8-732857DFA677}"/>
+                <a16:creationId xmlns:a16="http://schemas.microsoft.com/office/drawing/2014/main" id="{B0461C4A-29E9-488D-9C8F-EE54D5777B77}"/>
               </a:ext>
             </a:extLst>
           </p:cNvPr>
@@ -12947,7 +12947,7 @@
           <p:cNvPr id="24" name="">
             <a:extLst xmlns:a="http://schemas.openxmlformats.org/drawingml/2006/main">
               <a:ext uri="{FF2B5EF4-FFF2-40B4-BE49-F238E27FC236}">
-                <a16:creationId xmlns:a16="http://schemas.microsoft.com/office/drawing/2014/main" id="{76D19CF2-C82B-406E-A857-A8B355EAEBBF}"/>
+                <a16:creationId xmlns:a16="http://schemas.microsoft.com/office/drawing/2014/main" id="{581719AF-0CAC-4947-AA04-5AC9D23A92D7}"/>
               </a:ext>
             </a:extLst>
           </p:cNvPr>
@@ -12989,7 +12989,7 @@
           <p:cNvPr id="25" name="">
             <a:extLst xmlns:a="http://schemas.openxmlformats.org/drawingml/2006/main">
               <a:ext uri="{FF2B5EF4-FFF2-40B4-BE49-F238E27FC236}">
-                <a16:creationId xmlns:a16="http://schemas.microsoft.com/office/drawing/2014/main" id="{2294D96E-5302-4E65-81BF-E630D839B4F5}"/>
+                <a16:creationId xmlns:a16="http://schemas.microsoft.com/office/drawing/2014/main" id="{B6FCBC17-A962-4A53-A013-DB1943D623E3}"/>
               </a:ext>
             </a:extLst>
           </p:cNvPr>
@@ -13051,7 +13051,7 @@
           <p:cNvPr id="26" name="">
             <a:extLst xmlns:a="http://schemas.openxmlformats.org/drawingml/2006/main">
               <a:ext uri="{FF2B5EF4-FFF2-40B4-BE49-F238E27FC236}">
-                <a16:creationId xmlns:a16="http://schemas.microsoft.com/office/drawing/2014/main" id="{B8267C7D-D6CE-4A8D-9A43-7EC813B2954F}"/>
+                <a16:creationId xmlns:a16="http://schemas.microsoft.com/office/drawing/2014/main" id="{9E0FC949-CD66-4E78-B3B2-6DA26FE30FFA}"/>
               </a:ext>
             </a:extLst>
           </p:cNvPr>
@@ -13113,7 +13113,7 @@
           <p:cNvPr id="27" name="">
             <a:extLst xmlns:a="http://schemas.openxmlformats.org/drawingml/2006/main">
               <a:ext uri="{FF2B5EF4-FFF2-40B4-BE49-F238E27FC236}">
-                <a16:creationId xmlns:a16="http://schemas.microsoft.com/office/drawing/2014/main" id="{9FDA6585-E8B4-48B3-A4AE-EA8C2EA5B10A}"/>
+                <a16:creationId xmlns:a16="http://schemas.microsoft.com/office/drawing/2014/main" id="{81111837-1AF9-4683-A733-15925473C921}"/>
               </a:ext>
             </a:extLst>
           </p:cNvPr>
@@ -13173,7 +13173,7 @@
     </p:spTree>
     <p:extLst>
       <p:ext uri="{BB962C8B-B14F-4D97-AF65-F5344CB8AC3E}">
-        <p14:creationId xmlns:p14="http://schemas.microsoft.com/office/powerpoint/2010/main" val="1939421646"/>
+        <p14:creationId xmlns:p14="http://schemas.microsoft.com/office/powerpoint/2010/main" val="2104423932"/>
       </p:ext>
     </p:extLst>
   </p:cSld>
@@ -13197,7 +13197,7 @@
           <p:cNvPr id="21" name="">
             <a:extLst xmlns:a="http://schemas.openxmlformats.org/drawingml/2006/main">
               <a:ext uri="{FF2B5EF4-FFF2-40B4-BE49-F238E27FC236}">
-                <a16:creationId xmlns:a16="http://schemas.microsoft.com/office/drawing/2014/main" id="{2A6B145B-E986-4B3B-ADA7-90493902EA25}"/>
+                <a16:creationId xmlns:a16="http://schemas.microsoft.com/office/drawing/2014/main" id="{92051371-B36A-460C-9F05-41FAFEF149DE}"/>
               </a:ext>
             </a:extLst>
           </p:cNvPr>
@@ -13259,7 +13259,7 @@
           <p:cNvPr id="2" name="">
             <a:extLst xmlns:a="http://schemas.openxmlformats.org/drawingml/2006/main">
               <a:ext uri="{FF2B5EF4-FFF2-40B4-BE49-F238E27FC236}">
-                <a16:creationId xmlns:a16="http://schemas.microsoft.com/office/drawing/2014/main" id="{12F07220-8433-4D2D-A0F6-636BA6E8B238}"/>
+                <a16:creationId xmlns:a16="http://schemas.microsoft.com/office/drawing/2014/main" id="{A8748E2C-10D4-46A8-9717-A082FDFC68E1}"/>
               </a:ext>
             </a:extLst>
           </p:cNvPr>
@@ -13321,7 +13321,7 @@
           <p:cNvPr id="3" name="">
             <a:extLst xmlns:a="http://schemas.openxmlformats.org/drawingml/2006/main">
               <a:ext uri="{FF2B5EF4-FFF2-40B4-BE49-F238E27FC236}">
-                <a16:creationId xmlns:a16="http://schemas.microsoft.com/office/drawing/2014/main" id="{11E8B92D-F435-431E-816C-17DC6A6D8C8C}"/>
+                <a16:creationId xmlns:a16="http://schemas.microsoft.com/office/drawing/2014/main" id="{DD0D84F9-4997-423A-B31C-0F8B0FDBA753}"/>
               </a:ext>
             </a:extLst>
           </p:cNvPr>
@@ -13383,7 +13383,7 @@
           <p:cNvPr id="4" name="">
             <a:extLst xmlns:a="http://schemas.openxmlformats.org/drawingml/2006/main">
               <a:ext uri="{FF2B5EF4-FFF2-40B4-BE49-F238E27FC236}">
-                <a16:creationId xmlns:a16="http://schemas.microsoft.com/office/drawing/2014/main" id="{34E5BD4D-9E12-452D-8033-64D531F84DDF}"/>
+                <a16:creationId xmlns:a16="http://schemas.microsoft.com/office/drawing/2014/main" id="{E4D9F7CB-4F0E-4301-9806-7922A2B40C4E}"/>
               </a:ext>
             </a:extLst>
           </p:cNvPr>
@@ -13418,7 +13418,7 @@
           <p:cNvPr id="5" name="">
             <a:extLst xmlns:a="http://schemas.openxmlformats.org/drawingml/2006/main">
               <a:ext uri="{FF2B5EF4-FFF2-40B4-BE49-F238E27FC236}">
-                <a16:creationId xmlns:a16="http://schemas.microsoft.com/office/drawing/2014/main" id="{CBC8A5E0-B97F-44DB-9A66-7C493A10E874}"/>
+                <a16:creationId xmlns:a16="http://schemas.microsoft.com/office/drawing/2014/main" id="{2EFEC585-17E9-4875-82F6-0560EEA610D0}"/>
               </a:ext>
             </a:extLst>
           </p:cNvPr>
@@ -13480,7 +13480,7 @@
           <p:cNvPr id="6" name="">
             <a:extLst xmlns:a="http://schemas.openxmlformats.org/drawingml/2006/main">
               <a:ext uri="{FF2B5EF4-FFF2-40B4-BE49-F238E27FC236}">
-                <a16:creationId xmlns:a16="http://schemas.microsoft.com/office/drawing/2014/main" id="{47FA1C0A-DEDC-4DF6-A112-55221EF7E382}"/>
+                <a16:creationId xmlns:a16="http://schemas.microsoft.com/office/drawing/2014/main" id="{93F35AE5-12C6-49A1-8C7C-35EE35C5A851}"/>
               </a:ext>
             </a:extLst>
           </p:cNvPr>
@@ -13542,7 +13542,7 @@
           <p:cNvPr id="7" name="">
             <a:extLst xmlns:a="http://schemas.openxmlformats.org/drawingml/2006/main">
               <a:ext uri="{FF2B5EF4-FFF2-40B4-BE49-F238E27FC236}">
-                <a16:creationId xmlns:a16="http://schemas.microsoft.com/office/drawing/2014/main" id="{4F60D3B6-BA95-45E3-9A9B-7B6484F94375}"/>
+                <a16:creationId xmlns:a16="http://schemas.microsoft.com/office/drawing/2014/main" id="{61AD96F7-7E95-4345-9524-883F6880C7F7}"/>
               </a:ext>
             </a:extLst>
           </p:cNvPr>
@@ -13604,7 +13604,7 @@
           <p:cNvPr id="8" name="">
             <a:extLst xmlns:a="http://schemas.openxmlformats.org/drawingml/2006/main">
               <a:ext uri="{FF2B5EF4-FFF2-40B4-BE49-F238E27FC236}">
-                <a16:creationId xmlns:a16="http://schemas.microsoft.com/office/drawing/2014/main" id="{71C51135-A3A3-438C-97D2-BE22C60705C7}"/>
+                <a16:creationId xmlns:a16="http://schemas.microsoft.com/office/drawing/2014/main" id="{3A9C5FE9-E335-4F2C-AD0E-C7AD0E74D660}"/>
               </a:ext>
             </a:extLst>
           </p:cNvPr>
@@ -13639,7 +13639,7 @@
           <p:cNvPr id="9" name="">
             <a:extLst xmlns:a="http://schemas.openxmlformats.org/drawingml/2006/main">
               <a:ext uri="{FF2B5EF4-FFF2-40B4-BE49-F238E27FC236}">
-                <a16:creationId xmlns:a16="http://schemas.microsoft.com/office/drawing/2014/main" id="{658456B6-0D3F-4597-A0CF-8BC11B872857}"/>
+                <a16:creationId xmlns:a16="http://schemas.microsoft.com/office/drawing/2014/main" id="{81A1F0AF-1D8D-4814-9E62-BFFF08EF85FE}"/>
               </a:ext>
             </a:extLst>
           </p:cNvPr>
@@ -13701,7 +13701,7 @@
           <p:cNvPr id="10" name="">
             <a:extLst xmlns:a="http://schemas.openxmlformats.org/drawingml/2006/main">
               <a:ext uri="{FF2B5EF4-FFF2-40B4-BE49-F238E27FC236}">
-                <a16:creationId xmlns:a16="http://schemas.microsoft.com/office/drawing/2014/main" id="{D5E972EC-8E74-43D1-AB7C-C0049268870F}"/>
+                <a16:creationId xmlns:a16="http://schemas.microsoft.com/office/drawing/2014/main" id="{4FFED34D-FC30-463D-B485-5807F3CEB809}"/>
               </a:ext>
             </a:extLst>
           </p:cNvPr>
@@ -13763,7 +13763,7 @@
           <p:cNvPr id="11" name="">
             <a:extLst xmlns:a="http://schemas.openxmlformats.org/drawingml/2006/main">
               <a:ext uri="{FF2B5EF4-FFF2-40B4-BE49-F238E27FC236}">
-                <a16:creationId xmlns:a16="http://schemas.microsoft.com/office/drawing/2014/main" id="{6F1F58BC-3D78-4417-92F7-4F00FC5337EC}"/>
+                <a16:creationId xmlns:a16="http://schemas.microsoft.com/office/drawing/2014/main" id="{B8F5FC10-E735-43B5-8F8B-087159917E6A}"/>
               </a:ext>
             </a:extLst>
           </p:cNvPr>
@@ -13825,7 +13825,7 @@
           <p:cNvPr id="12" name="">
             <a:extLst xmlns:a="http://schemas.openxmlformats.org/drawingml/2006/main">
               <a:ext uri="{FF2B5EF4-FFF2-40B4-BE49-F238E27FC236}">
-                <a16:creationId xmlns:a16="http://schemas.microsoft.com/office/drawing/2014/main" id="{AD595276-0BDE-4783-9D52-EA08A56041EE}"/>
+                <a16:creationId xmlns:a16="http://schemas.microsoft.com/office/drawing/2014/main" id="{52CB55D6-1F0B-4D6A-8AB4-903BF185A37B}"/>
               </a:ext>
             </a:extLst>
           </p:cNvPr>
@@ -13860,7 +13860,7 @@
           <p:cNvPr id="13" name="">
             <a:extLst xmlns:a="http://schemas.openxmlformats.org/drawingml/2006/main">
               <a:ext uri="{FF2B5EF4-FFF2-40B4-BE49-F238E27FC236}">
-                <a16:creationId xmlns:a16="http://schemas.microsoft.com/office/drawing/2014/main" id="{34701040-880F-433F-BA46-CBA75014F2A4}"/>
+                <a16:creationId xmlns:a16="http://schemas.microsoft.com/office/drawing/2014/main" id="{5643E483-89A0-48C4-A4B3-DC6ECCE00DA1}"/>
               </a:ext>
             </a:extLst>
           </p:cNvPr>
@@ -13922,7 +13922,7 @@
           <p:cNvPr id="14" name="">
             <a:extLst xmlns:a="http://schemas.openxmlformats.org/drawingml/2006/main">
               <a:ext uri="{FF2B5EF4-FFF2-40B4-BE49-F238E27FC236}">
-                <a16:creationId xmlns:a16="http://schemas.microsoft.com/office/drawing/2014/main" id="{EDB8E6E0-80FE-4888-9565-99F1C4969720}"/>
+                <a16:creationId xmlns:a16="http://schemas.microsoft.com/office/drawing/2014/main" id="{AEB30B96-BC66-4F7E-951C-1406DEFF6379}"/>
               </a:ext>
             </a:extLst>
           </p:cNvPr>
@@ -13984,7 +13984,7 @@
           <p:cNvPr id="15" name="">
             <a:extLst xmlns:a="http://schemas.openxmlformats.org/drawingml/2006/main">
               <a:ext uri="{FF2B5EF4-FFF2-40B4-BE49-F238E27FC236}">
-                <a16:creationId xmlns:a16="http://schemas.microsoft.com/office/drawing/2014/main" id="{CCAC939D-FE5A-4215-BD07-1A980484F787}"/>
+                <a16:creationId xmlns:a16="http://schemas.microsoft.com/office/drawing/2014/main" id="{23CAAAF1-408E-455A-9ACE-02A407C6AB16}"/>
               </a:ext>
             </a:extLst>
           </p:cNvPr>
@@ -14046,7 +14046,7 @@
           <p:cNvPr id="16" name="">
             <a:extLst xmlns:a="http://schemas.openxmlformats.org/drawingml/2006/main">
               <a:ext uri="{FF2B5EF4-FFF2-40B4-BE49-F238E27FC236}">
-                <a16:creationId xmlns:a16="http://schemas.microsoft.com/office/drawing/2014/main" id="{4BCC19E0-64B2-416B-BFDC-633565D1635B}"/>
+                <a16:creationId xmlns:a16="http://schemas.microsoft.com/office/drawing/2014/main" id="{D6FC9500-9417-4879-9169-5B975F359DDF}"/>
               </a:ext>
             </a:extLst>
           </p:cNvPr>
@@ -14081,7 +14081,7 @@
           <p:cNvPr id="17" name="">
             <a:extLst xmlns:a="http://schemas.openxmlformats.org/drawingml/2006/main">
               <a:ext uri="{FF2B5EF4-FFF2-40B4-BE49-F238E27FC236}">
-                <a16:creationId xmlns:a16="http://schemas.microsoft.com/office/drawing/2014/main" id="{67F8D8A3-9AED-4652-AD0D-5806A5D32B33}"/>
+                <a16:creationId xmlns:a16="http://schemas.microsoft.com/office/drawing/2014/main" id="{8F7CA314-E4EE-4B64-B970-6FA3B8DFE8B2}"/>
               </a:ext>
             </a:extLst>
           </p:cNvPr>
@@ -14143,7 +14143,7 @@
           <p:cNvPr id="18" name="">
             <a:extLst xmlns:a="http://schemas.openxmlformats.org/drawingml/2006/main">
               <a:ext uri="{FF2B5EF4-FFF2-40B4-BE49-F238E27FC236}">
-                <a16:creationId xmlns:a16="http://schemas.microsoft.com/office/drawing/2014/main" id="{563599D4-F58D-40F3-BD83-DC192DE1EE72}"/>
+                <a16:creationId xmlns:a16="http://schemas.microsoft.com/office/drawing/2014/main" id="{F0D94787-FB9E-42D3-BB59-CF268D39B5B9}"/>
               </a:ext>
             </a:extLst>
           </p:cNvPr>
@@ -14205,7 +14205,7 @@
           <p:cNvPr id="19" name="">
             <a:extLst xmlns:a="http://schemas.openxmlformats.org/drawingml/2006/main">
               <a:ext uri="{FF2B5EF4-FFF2-40B4-BE49-F238E27FC236}">
-                <a16:creationId xmlns:a16="http://schemas.microsoft.com/office/drawing/2014/main" id="{27027517-9339-4A05-9EBE-335F4A1F6293}"/>
+                <a16:creationId xmlns:a16="http://schemas.microsoft.com/office/drawing/2014/main" id="{721FCA4F-5AC5-4563-913B-4E173177ECE9}"/>
               </a:ext>
             </a:extLst>
           </p:cNvPr>
@@ -14267,7 +14267,7 @@
           <p:cNvPr id="20" name="">
             <a:extLst xmlns:a="http://schemas.openxmlformats.org/drawingml/2006/main">
               <a:ext uri="{FF2B5EF4-FFF2-40B4-BE49-F238E27FC236}">
-                <a16:creationId xmlns:a16="http://schemas.microsoft.com/office/drawing/2014/main" id="{8F186A99-698B-4BC9-8E40-9E7AF404AF47}"/>
+                <a16:creationId xmlns:a16="http://schemas.microsoft.com/office/drawing/2014/main" id="{ED7F37E4-0FFF-442B-BA40-0CA3597A4474}"/>
               </a:ext>
             </a:extLst>
           </p:cNvPr>
@@ -14329,7 +14329,7 @@
     </p:spTree>
     <p:extLst>
       <p:ext uri="{BB962C8B-B14F-4D97-AF65-F5344CB8AC3E}">
-        <p14:creationId xmlns:p14="http://schemas.microsoft.com/office/powerpoint/2010/main" val="651932889"/>
+        <p14:creationId xmlns:p14="http://schemas.microsoft.com/office/powerpoint/2010/main" val="1868721947"/>
       </p:ext>
     </p:extLst>
   </p:cSld>
@@ -14353,7 +14353,7 @@
           <p:cNvPr id="17" name="">
             <a:extLst xmlns:a="http://schemas.openxmlformats.org/drawingml/2006/main">
               <a:ext uri="{FF2B5EF4-FFF2-40B4-BE49-F238E27FC236}">
-                <a16:creationId xmlns:a16="http://schemas.microsoft.com/office/drawing/2014/main" id="{92EDBC34-9582-434D-86C1-33DC28145EA7}"/>
+                <a16:creationId xmlns:a16="http://schemas.microsoft.com/office/drawing/2014/main" id="{4B3F3297-C8CE-4DE4-9952-0CE297BACDDC}"/>
               </a:ext>
             </a:extLst>
           </p:cNvPr>
@@ -14415,7 +14415,7 @@
           <p:cNvPr id="2" name="">
             <a:extLst xmlns:a="http://schemas.openxmlformats.org/drawingml/2006/main">
               <a:ext uri="{FF2B5EF4-FFF2-40B4-BE49-F238E27FC236}">
-                <a16:creationId xmlns:a16="http://schemas.microsoft.com/office/drawing/2014/main" id="{467AEAFC-5A89-41EC-BF62-ADD22DAE9B19}"/>
+                <a16:creationId xmlns:a16="http://schemas.microsoft.com/office/drawing/2014/main" id="{81F54C22-379D-4F6C-836C-171BFCDB1843}"/>
               </a:ext>
             </a:extLst>
           </p:cNvPr>
@@ -14477,7 +14477,7 @@
           <p:cNvPr id="3" name="">
             <a:extLst xmlns:a="http://schemas.openxmlformats.org/drawingml/2006/main">
               <a:ext uri="{FF2B5EF4-FFF2-40B4-BE49-F238E27FC236}">
-                <a16:creationId xmlns:a16="http://schemas.microsoft.com/office/drawing/2014/main" id="{8016C1A8-55D1-4A25-8AB7-2E78612992D6}"/>
+                <a16:creationId xmlns:a16="http://schemas.microsoft.com/office/drawing/2014/main" id="{08E464AA-8B0F-444D-8AE1-A1D6DE6F7F31}"/>
               </a:ext>
             </a:extLst>
           </p:cNvPr>
@@ -14539,7 +14539,7 @@
           <p:cNvPr id="4" name="">
             <a:extLst xmlns:a="http://schemas.openxmlformats.org/drawingml/2006/main">
               <a:ext uri="{FF2B5EF4-FFF2-40B4-BE49-F238E27FC236}">
-                <a16:creationId xmlns:a16="http://schemas.microsoft.com/office/drawing/2014/main" id="{240B558F-CDBB-4436-A91C-7C8DCC38CE9C}"/>
+                <a16:creationId xmlns:a16="http://schemas.microsoft.com/office/drawing/2014/main" id="{31AF370F-5E60-4FB9-8776-EE8A864DAC5D}"/>
               </a:ext>
             </a:extLst>
           </p:cNvPr>
@@ -14574,7 +14574,7 @@
           <p:cNvPr id="5" name="">
             <a:extLst xmlns:a="http://schemas.openxmlformats.org/drawingml/2006/main">
               <a:ext uri="{FF2B5EF4-FFF2-40B4-BE49-F238E27FC236}">
-                <a16:creationId xmlns:a16="http://schemas.microsoft.com/office/drawing/2014/main" id="{9FCE8AEF-B3B9-4D30-9D6B-E6BBCB6941B9}"/>
+                <a16:creationId xmlns:a16="http://schemas.microsoft.com/office/drawing/2014/main" id="{83334E21-7C89-4709-8905-27708AED7B64}"/>
               </a:ext>
             </a:extLst>
           </p:cNvPr>
@@ -14636,7 +14636,7 @@
           <p:cNvPr id="6" name="">
             <a:extLst xmlns:a="http://schemas.openxmlformats.org/drawingml/2006/main">
               <a:ext uri="{FF2B5EF4-FFF2-40B4-BE49-F238E27FC236}">
-                <a16:creationId xmlns:a16="http://schemas.microsoft.com/office/drawing/2014/main" id="{3E4D8F83-C37C-4EA9-978A-B06143CA7AA9}"/>
+                <a16:creationId xmlns:a16="http://schemas.microsoft.com/office/drawing/2014/main" id="{AA146F9D-D743-45D6-A4A7-6DF44FF03E1C}"/>
               </a:ext>
             </a:extLst>
           </p:cNvPr>
@@ -14698,7 +14698,7 @@
           <p:cNvPr id="7" name="">
             <a:extLst xmlns:a="http://schemas.openxmlformats.org/drawingml/2006/main">
               <a:ext uri="{FF2B5EF4-FFF2-40B4-BE49-F238E27FC236}">
-                <a16:creationId xmlns:a16="http://schemas.microsoft.com/office/drawing/2014/main" id="{74CD89E3-A2FE-4C24-8EE1-AEFA37B70918}"/>
+                <a16:creationId xmlns:a16="http://schemas.microsoft.com/office/drawing/2014/main" id="{8636DBB0-418A-4F9A-8D44-034AB5447C52}"/>
               </a:ext>
             </a:extLst>
           </p:cNvPr>
@@ -14760,7 +14760,7 @@
           <p:cNvPr id="8" name="">
             <a:extLst xmlns:a="http://schemas.openxmlformats.org/drawingml/2006/main">
               <a:ext uri="{FF2B5EF4-FFF2-40B4-BE49-F238E27FC236}">
-                <a16:creationId xmlns:a16="http://schemas.microsoft.com/office/drawing/2014/main" id="{309F7BE8-4518-4478-A7CC-7254632FD6AD}"/>
+                <a16:creationId xmlns:a16="http://schemas.microsoft.com/office/drawing/2014/main" id="{2F67E81B-705F-40E3-9DEE-372EE826B712}"/>
               </a:ext>
             </a:extLst>
           </p:cNvPr>
@@ -14824,7 +14824,7 @@
           <p:cNvPr id="9" name="">
             <a:extLst xmlns:a="http://schemas.openxmlformats.org/drawingml/2006/main">
               <a:ext uri="{FF2B5EF4-FFF2-40B4-BE49-F238E27FC236}">
-                <a16:creationId xmlns:a16="http://schemas.microsoft.com/office/drawing/2014/main" id="{62E1EFD4-7CB6-40CE-87F2-070810A9343F}"/>
+                <a16:creationId xmlns:a16="http://schemas.microsoft.com/office/drawing/2014/main" id="{20233D5D-79BB-4F48-8223-6B4D63FA5EC2}"/>
               </a:ext>
             </a:extLst>
           </p:cNvPr>
@@ -14886,7 +14886,7 @@
           <p:cNvPr id="10" name="">
             <a:extLst xmlns:a="http://schemas.openxmlformats.org/drawingml/2006/main">
               <a:ext uri="{FF2B5EF4-FFF2-40B4-BE49-F238E27FC236}">
-                <a16:creationId xmlns:a16="http://schemas.microsoft.com/office/drawing/2014/main" id="{E417FE37-609E-4E37-B18E-034060AE792D}"/>
+                <a16:creationId xmlns:a16="http://schemas.microsoft.com/office/drawing/2014/main" id="{7E2A9828-6B18-47BF-9461-D27C58DBBA7A}"/>
               </a:ext>
             </a:extLst>
           </p:cNvPr>
@@ -14921,7 +14921,7 @@
           <p:cNvPr id="11" name="">
             <a:extLst xmlns:a="http://schemas.openxmlformats.org/drawingml/2006/main">
               <a:ext uri="{FF2B5EF4-FFF2-40B4-BE49-F238E27FC236}">
-                <a16:creationId xmlns:a16="http://schemas.microsoft.com/office/drawing/2014/main" id="{4A23AF99-1AED-43D7-AB4F-CEE2D402B121}"/>
+                <a16:creationId xmlns:a16="http://schemas.microsoft.com/office/drawing/2014/main" id="{665A83DF-4617-4E77-B75E-4DC5C276B655}"/>
               </a:ext>
             </a:extLst>
           </p:cNvPr>
@@ -14983,7 +14983,7 @@
           <p:cNvPr id="12" name="">
             <a:extLst xmlns:a="http://schemas.openxmlformats.org/drawingml/2006/main">
               <a:ext uri="{FF2B5EF4-FFF2-40B4-BE49-F238E27FC236}">
-                <a16:creationId xmlns:a16="http://schemas.microsoft.com/office/drawing/2014/main" id="{85FCC2BA-407D-448B-9E2B-2BA6917F5641}"/>
+                <a16:creationId xmlns:a16="http://schemas.microsoft.com/office/drawing/2014/main" id="{3ACB1E4B-E93E-41BC-B115-22A46B14AD1F}"/>
               </a:ext>
             </a:extLst>
           </p:cNvPr>
@@ -15045,7 +15045,7 @@
           <p:cNvPr id="13" name="">
             <a:extLst xmlns:a="http://schemas.openxmlformats.org/drawingml/2006/main">
               <a:ext uri="{FF2B5EF4-FFF2-40B4-BE49-F238E27FC236}">
-                <a16:creationId xmlns:a16="http://schemas.microsoft.com/office/drawing/2014/main" id="{7D48B391-D1FF-4D08-87FD-853D91276182}"/>
+                <a16:creationId xmlns:a16="http://schemas.microsoft.com/office/drawing/2014/main" id="{F244CA53-6E4E-4EAF-891D-F62CE6A66F34}"/>
               </a:ext>
             </a:extLst>
           </p:cNvPr>
@@ -15107,7 +15107,7 @@
           <p:cNvPr id="14" name="">
             <a:extLst xmlns:a="http://schemas.openxmlformats.org/drawingml/2006/main">
               <a:ext uri="{FF2B5EF4-FFF2-40B4-BE49-F238E27FC236}">
-                <a16:creationId xmlns:a16="http://schemas.microsoft.com/office/drawing/2014/main" id="{C8413C66-EBDD-4C04-A06F-1548274FDED7}"/>
+                <a16:creationId xmlns:a16="http://schemas.microsoft.com/office/drawing/2014/main" id="{5022066E-3B78-4604-A39E-9146558F1423}"/>
               </a:ext>
             </a:extLst>
           </p:cNvPr>
@@ -15171,7 +15171,7 @@
           <p:cNvPr id="15" name="">
             <a:extLst xmlns:a="http://schemas.openxmlformats.org/drawingml/2006/main">
               <a:ext uri="{FF2B5EF4-FFF2-40B4-BE49-F238E27FC236}">
-                <a16:creationId xmlns:a16="http://schemas.microsoft.com/office/drawing/2014/main" id="{043AEF3D-064B-420E-B7BF-F9137AD5E0EA}"/>
+                <a16:creationId xmlns:a16="http://schemas.microsoft.com/office/drawing/2014/main" id="{8D97037C-237F-4B7A-976C-011A21AAE171}"/>
               </a:ext>
             </a:extLst>
           </p:cNvPr>
@@ -15233,7 +15233,7 @@
           <p:cNvPr id="16" name="">
             <a:extLst xmlns:a="http://schemas.openxmlformats.org/drawingml/2006/main">
               <a:ext uri="{FF2B5EF4-FFF2-40B4-BE49-F238E27FC236}">
-                <a16:creationId xmlns:a16="http://schemas.microsoft.com/office/drawing/2014/main" id="{A7669C79-E473-49AD-8E3C-3F6E5C45F9F7}"/>
+                <a16:creationId xmlns:a16="http://schemas.microsoft.com/office/drawing/2014/main" id="{5E5FA0A4-C28F-4F07-BE73-25F070AF29F6}"/>
               </a:ext>
             </a:extLst>
           </p:cNvPr>
@@ -15293,7 +15293,7 @@
     </p:spTree>
     <p:extLst>
       <p:ext uri="{BB962C8B-B14F-4D97-AF65-F5344CB8AC3E}">
-        <p14:creationId xmlns:p14="http://schemas.microsoft.com/office/powerpoint/2010/main" val="1229828407"/>
+        <p14:creationId xmlns:p14="http://schemas.microsoft.com/office/powerpoint/2010/main" val="2140932314"/>
       </p:ext>
     </p:extLst>
   </p:cSld>
@@ -15317,7 +15317,7 @@
           <p:cNvPr id="16" name="">
             <a:extLst xmlns:a="http://schemas.openxmlformats.org/drawingml/2006/main">
               <a:ext uri="{FF2B5EF4-FFF2-40B4-BE49-F238E27FC236}">
-                <a16:creationId xmlns:a16="http://schemas.microsoft.com/office/drawing/2014/main" id="{43E1F074-8E8A-4B19-8C59-321796227B4F}"/>
+                <a16:creationId xmlns:a16="http://schemas.microsoft.com/office/drawing/2014/main" id="{3CE4D468-20EC-447C-A710-4BC8882319CF}"/>
               </a:ext>
             </a:extLst>
           </p:cNvPr>
@@ -15379,7 +15379,7 @@
           <p:cNvPr id="2" name="">
             <a:extLst xmlns:a="http://schemas.openxmlformats.org/drawingml/2006/main">
               <a:ext uri="{FF2B5EF4-FFF2-40B4-BE49-F238E27FC236}">
-                <a16:creationId xmlns:a16="http://schemas.microsoft.com/office/drawing/2014/main" id="{B7ED495E-4C46-4E0A-B25F-0CFAF20BF3BF}"/>
+                <a16:creationId xmlns:a16="http://schemas.microsoft.com/office/drawing/2014/main" id="{B44A8C00-3C9D-441E-8F60-66656A7FA4E3}"/>
               </a:ext>
             </a:extLst>
           </p:cNvPr>
@@ -15441,7 +15441,7 @@
           <p:cNvPr id="3" name="">
             <a:extLst xmlns:a="http://schemas.openxmlformats.org/drawingml/2006/main">
               <a:ext uri="{FF2B5EF4-FFF2-40B4-BE49-F238E27FC236}">
-                <a16:creationId xmlns:a16="http://schemas.microsoft.com/office/drawing/2014/main" id="{349320C9-DDCF-41B0-B590-9D909ABD2FCE}"/>
+                <a16:creationId xmlns:a16="http://schemas.microsoft.com/office/drawing/2014/main" id="{2AF054E4-91F5-4103-A52F-ABF6F61509B2}"/>
               </a:ext>
             </a:extLst>
           </p:cNvPr>
@@ -15493,7 +15493,7 @@
                   <a:srgbClr val="5A6B7C"/>
                 </a:solidFill>
               </a:rPr>
-              <a:t>servicios/indicador_dolar.py usa la libreria oficial requests</a:t>
+              <a:t>servicios/indicador_dolar.py: dos proveedores en cadena y respaldo local</a:t>
             </a:r>
           </a:p>
         </p:txBody>
@@ -15503,7 +15503,7 @@
           <p:cNvPr id="4" name="">
             <a:extLst xmlns:a="http://schemas.openxmlformats.org/drawingml/2006/main">
               <a:ext uri="{FF2B5EF4-FFF2-40B4-BE49-F238E27FC236}">
-                <a16:creationId xmlns:a16="http://schemas.microsoft.com/office/drawing/2014/main" id="{AD09006F-DC42-4B4E-AD7D-5A6A949B2627}"/>
+                <a16:creationId xmlns:a16="http://schemas.microsoft.com/office/drawing/2014/main" id="{70E7A739-7A30-4E31-8BE8-4F106CA06E4A}"/>
               </a:ext>
             </a:extLst>
           </p:cNvPr>
@@ -15555,7 +15555,7 @@
                   <a:srgbClr val="0D233A"/>
                 </a:solidFill>
               </a:rPr>
-              <a:t>Consulta</a:t>
+              <a:t>1. Proveedor principal</a:t>
             </a:r>
           </a:p>
         </p:txBody>
@@ -15565,7 +15565,7 @@
           <p:cNvPr id="5" name="">
             <a:extLst xmlns:a="http://schemas.openxmlformats.org/drawingml/2006/main">
               <a:ext uri="{FF2B5EF4-FFF2-40B4-BE49-F238E27FC236}">
-                <a16:creationId xmlns:a16="http://schemas.microsoft.com/office/drawing/2014/main" id="{54E33FC4-F811-4A84-AD5F-BADAEDFF92E7}"/>
+                <a16:creationId xmlns:a16="http://schemas.microsoft.com/office/drawing/2014/main" id="{14166467-0829-4C57-91D9-E86220A62BC2}"/>
               </a:ext>
             </a:extLst>
           </p:cNvPr>
@@ -15629,7 +15629,7 @@
           <p:cNvPr id="6" name="">
             <a:extLst xmlns:a="http://schemas.openxmlformats.org/drawingml/2006/main">
               <a:ext uri="{FF2B5EF4-FFF2-40B4-BE49-F238E27FC236}">
-                <a16:creationId xmlns:a16="http://schemas.microsoft.com/office/drawing/2014/main" id="{AFC88F32-DA0A-43F3-9249-7F3325960CA3}"/>
+                <a16:creationId xmlns:a16="http://schemas.microsoft.com/office/drawing/2014/main" id="{FBB41670-D648-4F4A-8B15-03FEA40988F1}"/>
               </a:ext>
             </a:extLst>
           </p:cNvPr>
@@ -15681,7 +15681,7 @@
                   <a:srgbClr val="5A6B7C"/>
                 </a:solidFill>
               </a:rPr>
-              <a:t>La serie del dolar viene en el JSON; se toma el valor mas reciente.</a:t>
+              <a:t>Se toma el valor mas reciente de la serie del JSON.</a:t>
             </a:r>
           </a:p>
         </p:txBody>
@@ -15691,7 +15691,7 @@
           <p:cNvPr id="7" name="">
             <a:extLst xmlns:a="http://schemas.openxmlformats.org/drawingml/2006/main">
               <a:ext uri="{FF2B5EF4-FFF2-40B4-BE49-F238E27FC236}">
-                <a16:creationId xmlns:a16="http://schemas.microsoft.com/office/drawing/2014/main" id="{2E594581-172A-4852-AE20-D58D4177DBBE}"/>
+                <a16:creationId xmlns:a16="http://schemas.microsoft.com/office/drawing/2014/main" id="{9DCA6444-D77E-4319-925D-F21C79E1045A}"/>
               </a:ext>
             </a:extLst>
           </p:cNvPr>
@@ -15743,7 +15743,7 @@
                   <a:srgbClr val="0D233A"/>
                 </a:solidFill>
               </a:rPr>
-              <a:t>Conversion</a:t>
+              <a:t>2. Proveedor de respaldo</a:t>
             </a:r>
           </a:p>
         </p:txBody>
@@ -15753,7 +15753,7 @@
           <p:cNvPr id="8" name="">
             <a:extLst xmlns:a="http://schemas.openxmlformats.org/drawingml/2006/main">
               <a:ext uri="{FF2B5EF4-FFF2-40B4-BE49-F238E27FC236}">
-                <a16:creationId xmlns:a16="http://schemas.microsoft.com/office/drawing/2014/main" id="{BD45CEE5-D94A-44CC-AD04-3E95DE140435}"/>
+                <a16:creationId xmlns:a16="http://schemas.microsoft.com/office/drawing/2014/main" id="{DCF8E61F-4603-401F-8C61-BFA1804704AF}"/>
               </a:ext>
             </a:extLst>
           </p:cNvPr>
@@ -15807,7 +15807,7 @@
                   <a:srgbClr val="0D233A"/>
                 </a:solidFill>
               </a:rPr>
-              <a:t>ProductoElectronica.calcular_precio_final(valor_dolar)</a:t>
+              <a:t>https://findic.cl/api/dolar</a:t>
             </a:r>
           </a:p>
         </p:txBody>
@@ -15817,7 +15817,7 @@
           <p:cNvPr id="9" name="">
             <a:extLst xmlns:a="http://schemas.openxmlformats.org/drawingml/2006/main">
               <a:ext uri="{FF2B5EF4-FFF2-40B4-BE49-F238E27FC236}">
-                <a16:creationId xmlns:a16="http://schemas.microsoft.com/office/drawing/2014/main" id="{EF5087DF-A02C-4966-B59E-7DB3121B9473}"/>
+                <a16:creationId xmlns:a16="http://schemas.microsoft.com/office/drawing/2014/main" id="{8E1FCEC8-D8B3-4D4C-A59C-53E7671D4510}"/>
               </a:ext>
             </a:extLst>
           </p:cNvPr>
@@ -15869,7 +15869,7 @@
                   <a:srgbClr val="5A6B7C"/>
                 </a:solidFill>
               </a:rPr>
-              <a:t>precio_usd * valor_dolar, redondeado a pesos.</a:t>
+              <a:t>Si el principal no responde, se intenta con el segundo y se avisa cual se uso.</a:t>
             </a:r>
           </a:p>
         </p:txBody>
@@ -15879,7 +15879,7 @@
           <p:cNvPr id="10" name="">
             <a:extLst xmlns:a="http://schemas.openxmlformats.org/drawingml/2006/main">
               <a:ext uri="{FF2B5EF4-FFF2-40B4-BE49-F238E27FC236}">
-                <a16:creationId xmlns:a16="http://schemas.microsoft.com/office/drawing/2014/main" id="{0678B7E2-BBA8-4433-B335-6BE8302BCC98}"/>
+                <a16:creationId xmlns:a16="http://schemas.microsoft.com/office/drawing/2014/main" id="{E37E9CF9-8659-4A71-B1C0-B536B6B5FADB}"/>
               </a:ext>
             </a:extLst>
           </p:cNvPr>
@@ -15931,7 +15931,7 @@
                   <a:srgbClr val="0D233A"/>
                 </a:solidFill>
               </a:rPr>
-              <a:t>Si la API falla</a:t>
+              <a:t>3. Conversion a pesos</a:t>
             </a:r>
           </a:p>
         </p:txBody>
@@ -15941,7 +15941,7 @@
           <p:cNvPr id="11" name="">
             <a:extLst xmlns:a="http://schemas.openxmlformats.org/drawingml/2006/main">
               <a:ext uri="{FF2B5EF4-FFF2-40B4-BE49-F238E27FC236}">
-                <a16:creationId xmlns:a16="http://schemas.microsoft.com/office/drawing/2014/main" id="{8DD46EEF-F538-421B-AB4A-E8FF49F741E9}"/>
+                <a16:creationId xmlns:a16="http://schemas.microsoft.com/office/drawing/2014/main" id="{68D943B3-C191-4F5A-B81F-1F51FE5488E3}"/>
               </a:ext>
             </a:extLst>
           </p:cNvPr>
@@ -15995,7 +15995,7 @@
                   <a:srgbClr val="0D233A"/>
                 </a:solidFill>
               </a:rPr>
-              <a:t>except (RequestException, ValueError, KeyError)</a:t>
+              <a:t>ProductoElectronica.calcular_precio_final(valor_dolar)</a:t>
             </a:r>
           </a:p>
         </p:txBody>
@@ -16005,7 +16005,7 @@
           <p:cNvPr id="12" name="">
             <a:extLst xmlns:a="http://schemas.openxmlformats.org/drawingml/2006/main">
               <a:ext uri="{FF2B5EF4-FFF2-40B4-BE49-F238E27FC236}">
-                <a16:creationId xmlns:a16="http://schemas.microsoft.com/office/drawing/2014/main" id="{A06F7E51-B5EC-4065-B688-79B939108FC1}"/>
+                <a16:creationId xmlns:a16="http://schemas.microsoft.com/office/drawing/2014/main" id="{BCCD509B-36BB-46DE-A605-4E4F351A16B8}"/>
               </a:ext>
             </a:extLst>
           </p:cNvPr>
@@ -16057,7 +16057,7 @@
                   <a:srgbClr val="5A6B7C"/>
                 </a:solidFill>
               </a:rPr>
-              <a:t>Se lanza IndicadorNoDisponibleError con el motivo.</a:t>
+              <a:t>precio_usd * valor_dolar, redondeado a pesos.</a:t>
             </a:r>
           </a:p>
         </p:txBody>
@@ -16067,7 +16067,7 @@
           <p:cNvPr id="13" name="">
             <a:extLst xmlns:a="http://schemas.openxmlformats.org/drawingml/2006/main">
               <a:ext uri="{FF2B5EF4-FFF2-40B4-BE49-F238E27FC236}">
-                <a16:creationId xmlns:a16="http://schemas.microsoft.com/office/drawing/2014/main" id="{C6205EE1-D931-403B-8D11-77E99E909CCC}"/>
+                <a16:creationId xmlns:a16="http://schemas.microsoft.com/office/drawing/2014/main" id="{DE6DE98C-A7EB-425E-9E3D-5CC9B6D63EAB}"/>
               </a:ext>
             </a:extLst>
           </p:cNvPr>
@@ -16119,7 +16119,7 @@
                   <a:srgbClr val="0D233A"/>
                 </a:solidFill>
               </a:rPr>
-              <a:t>Continuidad</a:t>
+              <a:t>4. Ultimo respaldo</a:t>
             </a:r>
           </a:p>
         </p:txBody>
@@ -16129,7 +16129,7 @@
           <p:cNvPr id="14" name="">
             <a:extLst xmlns:a="http://schemas.openxmlformats.org/drawingml/2006/main">
               <a:ext uri="{FF2B5EF4-FFF2-40B4-BE49-F238E27FC236}">
-                <a16:creationId xmlns:a16="http://schemas.microsoft.com/office/drawing/2014/main" id="{4B7A386C-DEC5-4E86-96F5-86A0B017AB5A}"/>
+                <a16:creationId xmlns:a16="http://schemas.microsoft.com/office/drawing/2014/main" id="{AFA9A6B7-196B-4D8D-8F22-3871580EB2D0}"/>
               </a:ext>
             </a:extLst>
           </p:cNvPr>
@@ -16183,7 +16183,7 @@
                   <a:srgbClr val="0D233A"/>
                 </a:solidFill>
               </a:rPr>
-              <a:t>ultimo_valor_conocido()</a:t>
+              <a:t>datos/dolar_respaldo.json</a:t>
             </a:r>
           </a:p>
         </p:txBody>
@@ -16193,7 +16193,7 @@
           <p:cNvPr id="15" name="">
             <a:extLst xmlns:a="http://schemas.openxmlformats.org/drawingml/2006/main">
               <a:ext uri="{FF2B5EF4-FFF2-40B4-BE49-F238E27FC236}">
-                <a16:creationId xmlns:a16="http://schemas.microsoft.com/office/drawing/2014/main" id="{59546DEA-007E-474F-9F2E-C18E2B3F7FEF}"/>
+                <a16:creationId xmlns:a16="http://schemas.microsoft.com/office/drawing/2014/main" id="{C6D594E5-D8F6-4DC3-8EA8-F7AD5E73ADC0}"/>
               </a:ext>
             </a:extLst>
           </p:cNvPr>
@@ -16245,7 +16245,7 @@
                   <a:srgbClr val="5A6B7C"/>
                 </a:solidFill>
               </a:rPr>
-              <a:t>Se usa el respaldo en datos/dolar_respaldo.json y se avisa al operador.</a:t>
+              <a:t>Si fallan los dos proveedores, se usa el ultimo valor conocido y se informa.</a:t>
             </a:r>
           </a:p>
         </p:txBody>
@@ -16253,7 +16253,7 @@
     </p:spTree>
     <p:extLst>
       <p:ext uri="{BB962C8B-B14F-4D97-AF65-F5344CB8AC3E}">
-        <p14:creationId xmlns:p14="http://schemas.microsoft.com/office/powerpoint/2010/main" val="172821195"/>
+        <p14:creationId xmlns:p14="http://schemas.microsoft.com/office/powerpoint/2010/main" val="410206736"/>
       </p:ext>
     </p:extLst>
   </p:cSld>

</xml_diff>